<commit_message>
fixing up fig 2
</commit_message>
<xml_diff>
--- a/Output/Pub_figs/FIg2.pptx
+++ b/Output/Pub_figs/FIg2.pptx
@@ -2,19 +2,19 @@
 <file path=ppt/presentation.xml><?xml version="1.0" encoding="utf-8"?>
 <p:presentation xmlns:a="http://schemas.openxmlformats.org/drawingml/2006/main" xmlns:r="http://schemas.openxmlformats.org/officeDocument/2006/relationships" xmlns:p="http://schemas.openxmlformats.org/presentationml/2006/main" saveSubsetFonts="1" autoCompressPictures="0">
   <p:sldMasterIdLst>
-    <p:sldMasterId id="2147483732" r:id="rId1"/>
+    <p:sldMasterId id="2147483756" r:id="rId1"/>
   </p:sldMasterIdLst>
   <p:sldIdLst>
-    <p:sldId id="256" r:id="rId2"/>
+    <p:sldId id="257" r:id="rId2"/>
   </p:sldIdLst>
-  <p:sldSz cx="6858000" cy="7907338"/>
+  <p:sldSz cx="6480175" cy="6480175"/>
   <p:notesSz cx="6858000" cy="9144000"/>
   <p:defaultTextStyle>
     <a:defPPr>
       <a:defRPr lang="en-US"/>
     </a:defPPr>
-    <a:lvl1pPr marL="0" algn="l" defTabSz="914400" rtl="0" eaLnBrk="1" latinLnBrk="0" hangingPunct="1">
-      <a:defRPr sz="1800" kern="1200">
+    <a:lvl1pPr marL="0" algn="l" defTabSz="847100" rtl="0" eaLnBrk="1" latinLnBrk="0" hangingPunct="1">
+      <a:defRPr sz="1668" kern="1200">
         <a:solidFill>
           <a:schemeClr val="tx1"/>
         </a:solidFill>
@@ -23,8 +23,8 @@
         <a:cs typeface="+mn-cs"/>
       </a:defRPr>
     </a:lvl1pPr>
-    <a:lvl2pPr marL="457200" algn="l" defTabSz="914400" rtl="0" eaLnBrk="1" latinLnBrk="0" hangingPunct="1">
-      <a:defRPr sz="1800" kern="1200">
+    <a:lvl2pPr marL="423550" algn="l" defTabSz="847100" rtl="0" eaLnBrk="1" latinLnBrk="0" hangingPunct="1">
+      <a:defRPr sz="1668" kern="1200">
         <a:solidFill>
           <a:schemeClr val="tx1"/>
         </a:solidFill>
@@ -33,8 +33,8 @@
         <a:cs typeface="+mn-cs"/>
       </a:defRPr>
     </a:lvl2pPr>
-    <a:lvl3pPr marL="914400" algn="l" defTabSz="914400" rtl="0" eaLnBrk="1" latinLnBrk="0" hangingPunct="1">
-      <a:defRPr sz="1800" kern="1200">
+    <a:lvl3pPr marL="847100" algn="l" defTabSz="847100" rtl="0" eaLnBrk="1" latinLnBrk="0" hangingPunct="1">
+      <a:defRPr sz="1668" kern="1200">
         <a:solidFill>
           <a:schemeClr val="tx1"/>
         </a:solidFill>
@@ -43,8 +43,8 @@
         <a:cs typeface="+mn-cs"/>
       </a:defRPr>
     </a:lvl3pPr>
-    <a:lvl4pPr marL="1371600" algn="l" defTabSz="914400" rtl="0" eaLnBrk="1" latinLnBrk="0" hangingPunct="1">
-      <a:defRPr sz="1800" kern="1200">
+    <a:lvl4pPr marL="1270650" algn="l" defTabSz="847100" rtl="0" eaLnBrk="1" latinLnBrk="0" hangingPunct="1">
+      <a:defRPr sz="1668" kern="1200">
         <a:solidFill>
           <a:schemeClr val="tx1"/>
         </a:solidFill>
@@ -53,8 +53,8 @@
         <a:cs typeface="+mn-cs"/>
       </a:defRPr>
     </a:lvl4pPr>
-    <a:lvl5pPr marL="1828800" algn="l" defTabSz="914400" rtl="0" eaLnBrk="1" latinLnBrk="0" hangingPunct="1">
-      <a:defRPr sz="1800" kern="1200">
+    <a:lvl5pPr marL="1694200" algn="l" defTabSz="847100" rtl="0" eaLnBrk="1" latinLnBrk="0" hangingPunct="1">
+      <a:defRPr sz="1668" kern="1200">
         <a:solidFill>
           <a:schemeClr val="tx1"/>
         </a:solidFill>
@@ -63,8 +63,8 @@
         <a:cs typeface="+mn-cs"/>
       </a:defRPr>
     </a:lvl5pPr>
-    <a:lvl6pPr marL="2286000" algn="l" defTabSz="914400" rtl="0" eaLnBrk="1" latinLnBrk="0" hangingPunct="1">
-      <a:defRPr sz="1800" kern="1200">
+    <a:lvl6pPr marL="2117750" algn="l" defTabSz="847100" rtl="0" eaLnBrk="1" latinLnBrk="0" hangingPunct="1">
+      <a:defRPr sz="1668" kern="1200">
         <a:solidFill>
           <a:schemeClr val="tx1"/>
         </a:solidFill>
@@ -73,8 +73,8 @@
         <a:cs typeface="+mn-cs"/>
       </a:defRPr>
     </a:lvl6pPr>
-    <a:lvl7pPr marL="2743200" algn="l" defTabSz="914400" rtl="0" eaLnBrk="1" latinLnBrk="0" hangingPunct="1">
-      <a:defRPr sz="1800" kern="1200">
+    <a:lvl7pPr marL="2541300" algn="l" defTabSz="847100" rtl="0" eaLnBrk="1" latinLnBrk="0" hangingPunct="1">
+      <a:defRPr sz="1668" kern="1200">
         <a:solidFill>
           <a:schemeClr val="tx1"/>
         </a:solidFill>
@@ -83,8 +83,8 @@
         <a:cs typeface="+mn-cs"/>
       </a:defRPr>
     </a:lvl7pPr>
-    <a:lvl8pPr marL="3200400" algn="l" defTabSz="914400" rtl="0" eaLnBrk="1" latinLnBrk="0" hangingPunct="1">
-      <a:defRPr sz="1800" kern="1200">
+    <a:lvl8pPr marL="2964851" algn="l" defTabSz="847100" rtl="0" eaLnBrk="1" latinLnBrk="0" hangingPunct="1">
+      <a:defRPr sz="1668" kern="1200">
         <a:solidFill>
           <a:schemeClr val="tx1"/>
         </a:solidFill>
@@ -93,8 +93,8 @@
         <a:cs typeface="+mn-cs"/>
       </a:defRPr>
     </a:lvl8pPr>
-    <a:lvl9pPr marL="3657600" algn="l" defTabSz="914400" rtl="0" eaLnBrk="1" latinLnBrk="0" hangingPunct="1">
-      <a:defRPr sz="1800" kern="1200">
+    <a:lvl9pPr marL="3388401" algn="l" defTabSz="847100" rtl="0" eaLnBrk="1" latinLnBrk="0" hangingPunct="1">
+      <a:defRPr sz="1668" kern="1200">
         <a:solidFill>
           <a:schemeClr val="tx1"/>
         </a:solidFill>
@@ -104,6 +104,11 @@
       </a:defRPr>
     </a:lvl9pPr>
   </p:defaultTextStyle>
+  <p:extLst>
+    <p:ext uri="{EFAFB233-063F-42B5-8137-9DF3F51BA10A}">
+      <p15:sldGuideLst xmlns:p15="http://schemas.microsoft.com/office/powerpoint/2012/main"/>
+    </p:ext>
+  </p:extLst>
 </p:presentation>
 </file>
 
@@ -136,15 +141,15 @@
         </p:nvSpPr>
         <p:spPr>
           <a:xfrm>
-            <a:off x="514350" y="1294095"/>
-            <a:ext cx="5829300" cy="2752925"/>
+            <a:off x="486013" y="1060529"/>
+            <a:ext cx="5508149" cy="2256061"/>
           </a:xfrm>
         </p:spPr>
         <p:txBody>
           <a:bodyPr anchor="b"/>
           <a:lstStyle>
             <a:lvl1pPr algn="ctr">
-              <a:defRPr sz="4500"/>
+              <a:defRPr sz="4252"/>
             </a:lvl1pPr>
           </a:lstStyle>
           <a:p>
@@ -168,8 +173,8 @@
         </p:nvSpPr>
         <p:spPr>
           <a:xfrm>
-            <a:off x="857250" y="4153183"/>
-            <a:ext cx="5143500" cy="1909109"/>
+            <a:off x="810022" y="3403592"/>
+            <a:ext cx="4860131" cy="1564542"/>
           </a:xfrm>
         </p:spPr>
         <p:txBody>
@@ -177,39 +182,39 @@
           <a:lstStyle>
             <a:lvl1pPr marL="0" indent="0" algn="ctr">
               <a:buNone/>
-              <a:defRPr sz="1800"/>
+              <a:defRPr sz="1701"/>
             </a:lvl1pPr>
-            <a:lvl2pPr marL="342900" indent="0" algn="ctr">
-              <a:buNone/>
-              <a:defRPr sz="1500"/>
+            <a:lvl2pPr marL="324018" indent="0" algn="ctr">
+              <a:buNone/>
+              <a:defRPr sz="1417"/>
             </a:lvl2pPr>
-            <a:lvl3pPr marL="685800" indent="0" algn="ctr">
-              <a:buNone/>
-              <a:defRPr sz="1350"/>
+            <a:lvl3pPr marL="648035" indent="0" algn="ctr">
+              <a:buNone/>
+              <a:defRPr sz="1276"/>
             </a:lvl3pPr>
-            <a:lvl4pPr marL="1028700" indent="0" algn="ctr">
-              <a:buNone/>
-              <a:defRPr sz="1200"/>
+            <a:lvl4pPr marL="972053" indent="0" algn="ctr">
+              <a:buNone/>
+              <a:defRPr sz="1134"/>
             </a:lvl4pPr>
-            <a:lvl5pPr marL="1371600" indent="0" algn="ctr">
-              <a:buNone/>
-              <a:defRPr sz="1200"/>
+            <a:lvl5pPr marL="1296071" indent="0" algn="ctr">
+              <a:buNone/>
+              <a:defRPr sz="1134"/>
             </a:lvl5pPr>
-            <a:lvl6pPr marL="1714500" indent="0" algn="ctr">
-              <a:buNone/>
-              <a:defRPr sz="1200"/>
+            <a:lvl6pPr marL="1620088" indent="0" algn="ctr">
+              <a:buNone/>
+              <a:defRPr sz="1134"/>
             </a:lvl6pPr>
-            <a:lvl7pPr marL="2057400" indent="0" algn="ctr">
-              <a:buNone/>
-              <a:defRPr sz="1200"/>
+            <a:lvl7pPr marL="1944106" indent="0" algn="ctr">
+              <a:buNone/>
+              <a:defRPr sz="1134"/>
             </a:lvl7pPr>
-            <a:lvl8pPr marL="2400300" indent="0" algn="ctr">
-              <a:buNone/>
-              <a:defRPr sz="1200"/>
+            <a:lvl8pPr marL="2268123" indent="0" algn="ctr">
+              <a:buNone/>
+              <a:defRPr sz="1134"/>
             </a:lvl8pPr>
-            <a:lvl9pPr marL="2743200" indent="0" algn="ctr">
-              <a:buNone/>
-              <a:defRPr sz="1200"/>
+            <a:lvl9pPr marL="2592141" indent="0" algn="ctr">
+              <a:buNone/>
+              <a:defRPr sz="1134"/>
             </a:lvl9pPr>
           </a:lstStyle>
           <a:p>
@@ -238,7 +243,7 @@
           <a:p>
             <a:fld id="{34E58144-06BA-FC41-A5E7-C2DF4DBA87D5}" type="datetimeFigureOut">
               <a:rPr lang="en-US" smtClean="0"/>
-              <a:t>3/31/23</a:t>
+              <a:t>7/28/23</a:t>
             </a:fld>
             <a:endParaRPr lang="en-US"/>
           </a:p>
@@ -289,7 +294,7 @@
     </p:spTree>
     <p:extLst>
       <p:ext uri="{BB962C8B-B14F-4D97-AF65-F5344CB8AC3E}">
-        <p14:creationId xmlns:p14="http://schemas.microsoft.com/office/powerpoint/2010/main" val="3012926301"/>
+        <p14:creationId xmlns:p14="http://schemas.microsoft.com/office/powerpoint/2010/main" val="3031359068"/>
       </p:ext>
     </p:extLst>
   </p:cSld>
@@ -408,7 +413,7 @@
           <a:p>
             <a:fld id="{34E58144-06BA-FC41-A5E7-C2DF4DBA87D5}" type="datetimeFigureOut">
               <a:rPr lang="en-US" smtClean="0"/>
-              <a:t>3/31/23</a:t>
+              <a:t>7/28/23</a:t>
             </a:fld>
             <a:endParaRPr lang="en-US"/>
           </a:p>
@@ -459,7 +464,7 @@
     </p:spTree>
     <p:extLst>
       <p:ext uri="{BB962C8B-B14F-4D97-AF65-F5344CB8AC3E}">
-        <p14:creationId xmlns:p14="http://schemas.microsoft.com/office/powerpoint/2010/main" val="3395260511"/>
+        <p14:creationId xmlns:p14="http://schemas.microsoft.com/office/powerpoint/2010/main" val="1685938159"/>
       </p:ext>
     </p:extLst>
   </p:cSld>
@@ -498,8 +503,8 @@
         </p:nvSpPr>
         <p:spPr>
           <a:xfrm>
-            <a:off x="4907757" y="420993"/>
-            <a:ext cx="1478756" cy="6701103"/>
+            <a:off x="4637375" y="345009"/>
+            <a:ext cx="1397288" cy="5491649"/>
           </a:xfrm>
         </p:spPr>
         <p:txBody>
@@ -526,8 +531,8 @@
         </p:nvSpPr>
         <p:spPr>
           <a:xfrm>
-            <a:off x="471488" y="420993"/>
-            <a:ext cx="4350544" cy="6701103"/>
+            <a:off x="445512" y="345009"/>
+            <a:ext cx="4110861" cy="5491649"/>
           </a:xfrm>
         </p:spPr>
         <p:txBody>
@@ -588,7 +593,7 @@
           <a:p>
             <a:fld id="{34E58144-06BA-FC41-A5E7-C2DF4DBA87D5}" type="datetimeFigureOut">
               <a:rPr lang="en-US" smtClean="0"/>
-              <a:t>3/31/23</a:t>
+              <a:t>7/28/23</a:t>
             </a:fld>
             <a:endParaRPr lang="en-US"/>
           </a:p>
@@ -639,7 +644,7 @@
     </p:spTree>
     <p:extLst>
       <p:ext uri="{BB962C8B-B14F-4D97-AF65-F5344CB8AC3E}">
-        <p14:creationId xmlns:p14="http://schemas.microsoft.com/office/powerpoint/2010/main" val="2292977535"/>
+        <p14:creationId xmlns:p14="http://schemas.microsoft.com/office/powerpoint/2010/main" val="1824450794"/>
       </p:ext>
     </p:extLst>
   </p:cSld>
@@ -758,7 +763,7 @@
           <a:p>
             <a:fld id="{34E58144-06BA-FC41-A5E7-C2DF4DBA87D5}" type="datetimeFigureOut">
               <a:rPr lang="en-US" smtClean="0"/>
-              <a:t>3/31/23</a:t>
+              <a:t>7/28/23</a:t>
             </a:fld>
             <a:endParaRPr lang="en-US"/>
           </a:p>
@@ -809,7 +814,7 @@
     </p:spTree>
     <p:extLst>
       <p:ext uri="{BB962C8B-B14F-4D97-AF65-F5344CB8AC3E}">
-        <p14:creationId xmlns:p14="http://schemas.microsoft.com/office/powerpoint/2010/main" val="2214675009"/>
+        <p14:creationId xmlns:p14="http://schemas.microsoft.com/office/powerpoint/2010/main" val="1628053213"/>
       </p:ext>
     </p:extLst>
   </p:cSld>
@@ -848,15 +853,15 @@
         </p:nvSpPr>
         <p:spPr>
           <a:xfrm>
-            <a:off x="467916" y="1971346"/>
-            <a:ext cx="5915025" cy="3289232"/>
+            <a:off x="442137" y="1615546"/>
+            <a:ext cx="5589151" cy="2695572"/>
           </a:xfrm>
         </p:spPr>
         <p:txBody>
           <a:bodyPr anchor="b"/>
           <a:lstStyle>
             <a:lvl1pPr>
-              <a:defRPr sz="4500"/>
+              <a:defRPr sz="4252"/>
             </a:lvl1pPr>
           </a:lstStyle>
           <a:p>
@@ -880,8 +885,8 @@
         </p:nvSpPr>
         <p:spPr>
           <a:xfrm>
-            <a:off x="467916" y="5291695"/>
-            <a:ext cx="5915025" cy="1729730"/>
+            <a:off x="442137" y="4336619"/>
+            <a:ext cx="5589151" cy="1417538"/>
           </a:xfrm>
         </p:spPr>
         <p:txBody>
@@ -889,15 +894,15 @@
           <a:lstStyle>
             <a:lvl1pPr marL="0" indent="0">
               <a:buNone/>
-              <a:defRPr sz="1800">
+              <a:defRPr sz="1701">
                 <a:solidFill>
                   <a:schemeClr val="tx1"/>
                 </a:solidFill>
               </a:defRPr>
             </a:lvl1pPr>
-            <a:lvl2pPr marL="342900" indent="0">
-              <a:buNone/>
-              <a:defRPr sz="1500">
+            <a:lvl2pPr marL="324018" indent="0">
+              <a:buNone/>
+              <a:defRPr sz="1417">
                 <a:solidFill>
                   <a:schemeClr val="tx1">
                     <a:tint val="75000"/>
@@ -905,9 +910,9 @@
                 </a:solidFill>
               </a:defRPr>
             </a:lvl2pPr>
-            <a:lvl3pPr marL="685800" indent="0">
-              <a:buNone/>
-              <a:defRPr sz="1350">
+            <a:lvl3pPr marL="648035" indent="0">
+              <a:buNone/>
+              <a:defRPr sz="1276">
                 <a:solidFill>
                   <a:schemeClr val="tx1">
                     <a:tint val="75000"/>
@@ -915,9 +920,9 @@
                 </a:solidFill>
               </a:defRPr>
             </a:lvl3pPr>
-            <a:lvl4pPr marL="1028700" indent="0">
-              <a:buNone/>
-              <a:defRPr sz="1200">
+            <a:lvl4pPr marL="972053" indent="0">
+              <a:buNone/>
+              <a:defRPr sz="1134">
                 <a:solidFill>
                   <a:schemeClr val="tx1">
                     <a:tint val="75000"/>
@@ -925,9 +930,9 @@
                 </a:solidFill>
               </a:defRPr>
             </a:lvl4pPr>
-            <a:lvl5pPr marL="1371600" indent="0">
-              <a:buNone/>
-              <a:defRPr sz="1200">
+            <a:lvl5pPr marL="1296071" indent="0">
+              <a:buNone/>
+              <a:defRPr sz="1134">
                 <a:solidFill>
                   <a:schemeClr val="tx1">
                     <a:tint val="75000"/>
@@ -935,9 +940,9 @@
                 </a:solidFill>
               </a:defRPr>
             </a:lvl5pPr>
-            <a:lvl6pPr marL="1714500" indent="0">
-              <a:buNone/>
-              <a:defRPr sz="1200">
+            <a:lvl6pPr marL="1620088" indent="0">
+              <a:buNone/>
+              <a:defRPr sz="1134">
                 <a:solidFill>
                   <a:schemeClr val="tx1">
                     <a:tint val="75000"/>
@@ -945,9 +950,9 @@
                 </a:solidFill>
               </a:defRPr>
             </a:lvl6pPr>
-            <a:lvl7pPr marL="2057400" indent="0">
-              <a:buNone/>
-              <a:defRPr sz="1200">
+            <a:lvl7pPr marL="1944106" indent="0">
+              <a:buNone/>
+              <a:defRPr sz="1134">
                 <a:solidFill>
                   <a:schemeClr val="tx1">
                     <a:tint val="75000"/>
@@ -955,9 +960,9 @@
                 </a:solidFill>
               </a:defRPr>
             </a:lvl7pPr>
-            <a:lvl8pPr marL="2400300" indent="0">
-              <a:buNone/>
-              <a:defRPr sz="1200">
+            <a:lvl8pPr marL="2268123" indent="0">
+              <a:buNone/>
+              <a:defRPr sz="1134">
                 <a:solidFill>
                   <a:schemeClr val="tx1">
                     <a:tint val="75000"/>
@@ -965,9 +970,9 @@
                 </a:solidFill>
               </a:defRPr>
             </a:lvl8pPr>
-            <a:lvl9pPr marL="2743200" indent="0">
-              <a:buNone/>
-              <a:defRPr sz="1200">
+            <a:lvl9pPr marL="2592141" indent="0">
+              <a:buNone/>
+              <a:defRPr sz="1134">
                 <a:solidFill>
                   <a:schemeClr val="tx1">
                     <a:tint val="75000"/>
@@ -1002,7 +1007,7 @@
           <a:p>
             <a:fld id="{34E58144-06BA-FC41-A5E7-C2DF4DBA87D5}" type="datetimeFigureOut">
               <a:rPr lang="en-US" smtClean="0"/>
-              <a:t>3/31/23</a:t>
+              <a:t>7/28/23</a:t>
             </a:fld>
             <a:endParaRPr lang="en-US"/>
           </a:p>
@@ -1053,7 +1058,7 @@
     </p:spTree>
     <p:extLst>
       <p:ext uri="{BB962C8B-B14F-4D97-AF65-F5344CB8AC3E}">
-        <p14:creationId xmlns:p14="http://schemas.microsoft.com/office/powerpoint/2010/main" val="3028993582"/>
+        <p14:creationId xmlns:p14="http://schemas.microsoft.com/office/powerpoint/2010/main" val="4219435126"/>
       </p:ext>
     </p:extLst>
   </p:cSld>
@@ -1115,8 +1120,8 @@
         </p:nvSpPr>
         <p:spPr>
           <a:xfrm>
-            <a:off x="471488" y="2104963"/>
-            <a:ext cx="2914650" cy="5017133"/>
+            <a:off x="445512" y="1725046"/>
+            <a:ext cx="2754074" cy="4111612"/>
           </a:xfrm>
         </p:spPr>
         <p:txBody>
@@ -1172,8 +1177,8 @@
         </p:nvSpPr>
         <p:spPr>
           <a:xfrm>
-            <a:off x="3471863" y="2104963"/>
-            <a:ext cx="2914650" cy="5017133"/>
+            <a:off x="3280589" y="1725046"/>
+            <a:ext cx="2754074" cy="4111612"/>
           </a:xfrm>
         </p:spPr>
         <p:txBody>
@@ -1234,7 +1239,7 @@
           <a:p>
             <a:fld id="{34E58144-06BA-FC41-A5E7-C2DF4DBA87D5}" type="datetimeFigureOut">
               <a:rPr lang="en-US" smtClean="0"/>
-              <a:t>3/31/23</a:t>
+              <a:t>7/28/23</a:t>
             </a:fld>
             <a:endParaRPr lang="en-US"/>
           </a:p>
@@ -1285,7 +1290,7 @@
     </p:spTree>
     <p:extLst>
       <p:ext uri="{BB962C8B-B14F-4D97-AF65-F5344CB8AC3E}">
-        <p14:creationId xmlns:p14="http://schemas.microsoft.com/office/powerpoint/2010/main" val="933941202"/>
+        <p14:creationId xmlns:p14="http://schemas.microsoft.com/office/powerpoint/2010/main" val="6547600"/>
       </p:ext>
     </p:extLst>
   </p:cSld>
@@ -1324,8 +1329,8 @@
         </p:nvSpPr>
         <p:spPr>
           <a:xfrm>
-            <a:off x="472381" y="420994"/>
-            <a:ext cx="5915025" cy="1528387"/>
+            <a:off x="446356" y="345011"/>
+            <a:ext cx="5589151" cy="1252534"/>
           </a:xfrm>
         </p:spPr>
         <p:txBody>
@@ -1352,8 +1357,8 @@
         </p:nvSpPr>
         <p:spPr>
           <a:xfrm>
-            <a:off x="472381" y="1938397"/>
-            <a:ext cx="2901255" cy="949978"/>
+            <a:off x="446357" y="1588543"/>
+            <a:ext cx="2741417" cy="778521"/>
           </a:xfrm>
         </p:spPr>
         <p:txBody>
@@ -1361,39 +1366,39 @@
           <a:lstStyle>
             <a:lvl1pPr marL="0" indent="0">
               <a:buNone/>
-              <a:defRPr sz="1800" b="1"/>
+              <a:defRPr sz="1701" b="1"/>
             </a:lvl1pPr>
-            <a:lvl2pPr marL="342900" indent="0">
-              <a:buNone/>
-              <a:defRPr sz="1500" b="1"/>
+            <a:lvl2pPr marL="324018" indent="0">
+              <a:buNone/>
+              <a:defRPr sz="1417" b="1"/>
             </a:lvl2pPr>
-            <a:lvl3pPr marL="685800" indent="0">
-              <a:buNone/>
-              <a:defRPr sz="1350" b="1"/>
+            <a:lvl3pPr marL="648035" indent="0">
+              <a:buNone/>
+              <a:defRPr sz="1276" b="1"/>
             </a:lvl3pPr>
-            <a:lvl4pPr marL="1028700" indent="0">
-              <a:buNone/>
-              <a:defRPr sz="1200" b="1"/>
+            <a:lvl4pPr marL="972053" indent="0">
+              <a:buNone/>
+              <a:defRPr sz="1134" b="1"/>
             </a:lvl4pPr>
-            <a:lvl5pPr marL="1371600" indent="0">
-              <a:buNone/>
-              <a:defRPr sz="1200" b="1"/>
+            <a:lvl5pPr marL="1296071" indent="0">
+              <a:buNone/>
+              <a:defRPr sz="1134" b="1"/>
             </a:lvl5pPr>
-            <a:lvl6pPr marL="1714500" indent="0">
-              <a:buNone/>
-              <a:defRPr sz="1200" b="1"/>
+            <a:lvl6pPr marL="1620088" indent="0">
+              <a:buNone/>
+              <a:defRPr sz="1134" b="1"/>
             </a:lvl6pPr>
-            <a:lvl7pPr marL="2057400" indent="0">
-              <a:buNone/>
-              <a:defRPr sz="1200" b="1"/>
+            <a:lvl7pPr marL="1944106" indent="0">
+              <a:buNone/>
+              <a:defRPr sz="1134" b="1"/>
             </a:lvl7pPr>
-            <a:lvl8pPr marL="2400300" indent="0">
-              <a:buNone/>
-              <a:defRPr sz="1200" b="1"/>
+            <a:lvl8pPr marL="2268123" indent="0">
+              <a:buNone/>
+              <a:defRPr sz="1134" b="1"/>
             </a:lvl8pPr>
-            <a:lvl9pPr marL="2743200" indent="0">
-              <a:buNone/>
-              <a:defRPr sz="1200" b="1"/>
+            <a:lvl9pPr marL="2592141" indent="0">
+              <a:buNone/>
+              <a:defRPr sz="1134" b="1"/>
             </a:lvl9pPr>
           </a:lstStyle>
           <a:p>
@@ -1417,8 +1422,8 @@
         </p:nvSpPr>
         <p:spPr>
           <a:xfrm>
-            <a:off x="472381" y="2888375"/>
-            <a:ext cx="2901255" cy="4248364"/>
+            <a:off x="446357" y="2367064"/>
+            <a:ext cx="2741417" cy="3481594"/>
           </a:xfrm>
         </p:spPr>
         <p:txBody>
@@ -1474,8 +1479,8 @@
         </p:nvSpPr>
         <p:spPr>
           <a:xfrm>
-            <a:off x="3471863" y="1938397"/>
-            <a:ext cx="2915543" cy="949978"/>
+            <a:off x="3280589" y="1588543"/>
+            <a:ext cx="2754918" cy="778521"/>
           </a:xfrm>
         </p:spPr>
         <p:txBody>
@@ -1483,39 +1488,39 @@
           <a:lstStyle>
             <a:lvl1pPr marL="0" indent="0">
               <a:buNone/>
-              <a:defRPr sz="1800" b="1"/>
+              <a:defRPr sz="1701" b="1"/>
             </a:lvl1pPr>
-            <a:lvl2pPr marL="342900" indent="0">
-              <a:buNone/>
-              <a:defRPr sz="1500" b="1"/>
+            <a:lvl2pPr marL="324018" indent="0">
+              <a:buNone/>
+              <a:defRPr sz="1417" b="1"/>
             </a:lvl2pPr>
-            <a:lvl3pPr marL="685800" indent="0">
-              <a:buNone/>
-              <a:defRPr sz="1350" b="1"/>
+            <a:lvl3pPr marL="648035" indent="0">
+              <a:buNone/>
+              <a:defRPr sz="1276" b="1"/>
             </a:lvl3pPr>
-            <a:lvl4pPr marL="1028700" indent="0">
-              <a:buNone/>
-              <a:defRPr sz="1200" b="1"/>
+            <a:lvl4pPr marL="972053" indent="0">
+              <a:buNone/>
+              <a:defRPr sz="1134" b="1"/>
             </a:lvl4pPr>
-            <a:lvl5pPr marL="1371600" indent="0">
-              <a:buNone/>
-              <a:defRPr sz="1200" b="1"/>
+            <a:lvl5pPr marL="1296071" indent="0">
+              <a:buNone/>
+              <a:defRPr sz="1134" b="1"/>
             </a:lvl5pPr>
-            <a:lvl6pPr marL="1714500" indent="0">
-              <a:buNone/>
-              <a:defRPr sz="1200" b="1"/>
+            <a:lvl6pPr marL="1620088" indent="0">
+              <a:buNone/>
+              <a:defRPr sz="1134" b="1"/>
             </a:lvl6pPr>
-            <a:lvl7pPr marL="2057400" indent="0">
-              <a:buNone/>
-              <a:defRPr sz="1200" b="1"/>
+            <a:lvl7pPr marL="1944106" indent="0">
+              <a:buNone/>
+              <a:defRPr sz="1134" b="1"/>
             </a:lvl7pPr>
-            <a:lvl8pPr marL="2400300" indent="0">
-              <a:buNone/>
-              <a:defRPr sz="1200" b="1"/>
+            <a:lvl8pPr marL="2268123" indent="0">
+              <a:buNone/>
+              <a:defRPr sz="1134" b="1"/>
             </a:lvl8pPr>
-            <a:lvl9pPr marL="2743200" indent="0">
-              <a:buNone/>
-              <a:defRPr sz="1200" b="1"/>
+            <a:lvl9pPr marL="2592141" indent="0">
+              <a:buNone/>
+              <a:defRPr sz="1134" b="1"/>
             </a:lvl9pPr>
           </a:lstStyle>
           <a:p>
@@ -1539,8 +1544,8 @@
         </p:nvSpPr>
         <p:spPr>
           <a:xfrm>
-            <a:off x="3471863" y="2888375"/>
-            <a:ext cx="2915543" cy="4248364"/>
+            <a:off x="3280589" y="2367064"/>
+            <a:ext cx="2754918" cy="3481594"/>
           </a:xfrm>
         </p:spPr>
         <p:txBody>
@@ -1601,7 +1606,7 @@
           <a:p>
             <a:fld id="{34E58144-06BA-FC41-A5E7-C2DF4DBA87D5}" type="datetimeFigureOut">
               <a:rPr lang="en-US" smtClean="0"/>
-              <a:t>3/31/23</a:t>
+              <a:t>7/28/23</a:t>
             </a:fld>
             <a:endParaRPr lang="en-US"/>
           </a:p>
@@ -1652,7 +1657,7 @@
     </p:spTree>
     <p:extLst>
       <p:ext uri="{BB962C8B-B14F-4D97-AF65-F5344CB8AC3E}">
-        <p14:creationId xmlns:p14="http://schemas.microsoft.com/office/powerpoint/2010/main" val="1101737859"/>
+        <p14:creationId xmlns:p14="http://schemas.microsoft.com/office/powerpoint/2010/main" val="3193308985"/>
       </p:ext>
     </p:extLst>
   </p:cSld>
@@ -1719,7 +1724,7 @@
           <a:p>
             <a:fld id="{34E58144-06BA-FC41-A5E7-C2DF4DBA87D5}" type="datetimeFigureOut">
               <a:rPr lang="en-US" smtClean="0"/>
-              <a:t>3/31/23</a:t>
+              <a:t>7/28/23</a:t>
             </a:fld>
             <a:endParaRPr lang="en-US"/>
           </a:p>
@@ -1770,7 +1775,7 @@
     </p:spTree>
     <p:extLst>
       <p:ext uri="{BB962C8B-B14F-4D97-AF65-F5344CB8AC3E}">
-        <p14:creationId xmlns:p14="http://schemas.microsoft.com/office/powerpoint/2010/main" val="1472802825"/>
+        <p14:creationId xmlns:p14="http://schemas.microsoft.com/office/powerpoint/2010/main" val="902836754"/>
       </p:ext>
     </p:extLst>
   </p:cSld>
@@ -1814,7 +1819,7 @@
           <a:p>
             <a:fld id="{34E58144-06BA-FC41-A5E7-C2DF4DBA87D5}" type="datetimeFigureOut">
               <a:rPr lang="en-US" smtClean="0"/>
-              <a:t>3/31/23</a:t>
+              <a:t>7/28/23</a:t>
             </a:fld>
             <a:endParaRPr lang="en-US"/>
           </a:p>
@@ -1865,7 +1870,7 @@
     </p:spTree>
     <p:extLst>
       <p:ext uri="{BB962C8B-B14F-4D97-AF65-F5344CB8AC3E}">
-        <p14:creationId xmlns:p14="http://schemas.microsoft.com/office/powerpoint/2010/main" val="1304298182"/>
+        <p14:creationId xmlns:p14="http://schemas.microsoft.com/office/powerpoint/2010/main" val="1223099481"/>
       </p:ext>
     </p:extLst>
   </p:cSld>
@@ -1904,15 +1909,15 @@
         </p:nvSpPr>
         <p:spPr>
           <a:xfrm>
-            <a:off x="472381" y="527156"/>
-            <a:ext cx="2211884" cy="1845046"/>
+            <a:off x="446356" y="432012"/>
+            <a:ext cx="2090025" cy="1512041"/>
           </a:xfrm>
         </p:spPr>
         <p:txBody>
           <a:bodyPr anchor="b"/>
           <a:lstStyle>
             <a:lvl1pPr>
-              <a:defRPr sz="2400"/>
+              <a:defRPr sz="2268"/>
             </a:lvl1pPr>
           </a:lstStyle>
           <a:p>
@@ -1936,39 +1941,39 @@
         </p:nvSpPr>
         <p:spPr>
           <a:xfrm>
-            <a:off x="2915543" y="1138512"/>
-            <a:ext cx="3471863" cy="5619335"/>
+            <a:off x="2754918" y="933027"/>
+            <a:ext cx="3280589" cy="4605124"/>
           </a:xfrm>
         </p:spPr>
         <p:txBody>
           <a:bodyPr/>
           <a:lstStyle>
             <a:lvl1pPr>
-              <a:defRPr sz="2400"/>
+              <a:defRPr sz="2268"/>
             </a:lvl1pPr>
             <a:lvl2pPr>
-              <a:defRPr sz="2100"/>
+              <a:defRPr sz="1984"/>
             </a:lvl2pPr>
             <a:lvl3pPr>
-              <a:defRPr sz="1800"/>
+              <a:defRPr sz="1701"/>
             </a:lvl3pPr>
             <a:lvl4pPr>
-              <a:defRPr sz="1500"/>
+              <a:defRPr sz="1417"/>
             </a:lvl4pPr>
             <a:lvl5pPr>
-              <a:defRPr sz="1500"/>
+              <a:defRPr sz="1417"/>
             </a:lvl5pPr>
             <a:lvl6pPr>
-              <a:defRPr sz="1500"/>
+              <a:defRPr sz="1417"/>
             </a:lvl6pPr>
             <a:lvl7pPr>
-              <a:defRPr sz="1500"/>
+              <a:defRPr sz="1417"/>
             </a:lvl7pPr>
             <a:lvl8pPr>
-              <a:defRPr sz="1500"/>
+              <a:defRPr sz="1417"/>
             </a:lvl8pPr>
             <a:lvl9pPr>
-              <a:defRPr sz="1500"/>
+              <a:defRPr sz="1417"/>
             </a:lvl9pPr>
           </a:lstStyle>
           <a:p>
@@ -2021,8 +2026,8 @@
         </p:nvSpPr>
         <p:spPr>
           <a:xfrm>
-            <a:off x="472381" y="2372201"/>
-            <a:ext cx="2211884" cy="4394797"/>
+            <a:off x="446356" y="1944052"/>
+            <a:ext cx="2090025" cy="3601598"/>
           </a:xfrm>
         </p:spPr>
         <p:txBody>
@@ -2030,39 +2035,39 @@
           <a:lstStyle>
             <a:lvl1pPr marL="0" indent="0">
               <a:buNone/>
-              <a:defRPr sz="1200"/>
+              <a:defRPr sz="1134"/>
             </a:lvl1pPr>
-            <a:lvl2pPr marL="342900" indent="0">
-              <a:buNone/>
-              <a:defRPr sz="1050"/>
+            <a:lvl2pPr marL="324018" indent="0">
+              <a:buNone/>
+              <a:defRPr sz="992"/>
             </a:lvl2pPr>
-            <a:lvl3pPr marL="685800" indent="0">
-              <a:buNone/>
-              <a:defRPr sz="900"/>
+            <a:lvl3pPr marL="648035" indent="0">
+              <a:buNone/>
+              <a:defRPr sz="850"/>
             </a:lvl3pPr>
-            <a:lvl4pPr marL="1028700" indent="0">
-              <a:buNone/>
-              <a:defRPr sz="750"/>
+            <a:lvl4pPr marL="972053" indent="0">
+              <a:buNone/>
+              <a:defRPr sz="709"/>
             </a:lvl4pPr>
-            <a:lvl5pPr marL="1371600" indent="0">
-              <a:buNone/>
-              <a:defRPr sz="750"/>
+            <a:lvl5pPr marL="1296071" indent="0">
+              <a:buNone/>
+              <a:defRPr sz="709"/>
             </a:lvl5pPr>
-            <a:lvl6pPr marL="1714500" indent="0">
-              <a:buNone/>
-              <a:defRPr sz="750"/>
+            <a:lvl6pPr marL="1620088" indent="0">
+              <a:buNone/>
+              <a:defRPr sz="709"/>
             </a:lvl6pPr>
-            <a:lvl7pPr marL="2057400" indent="0">
-              <a:buNone/>
-              <a:defRPr sz="750"/>
+            <a:lvl7pPr marL="1944106" indent="0">
+              <a:buNone/>
+              <a:defRPr sz="709"/>
             </a:lvl7pPr>
-            <a:lvl8pPr marL="2400300" indent="0">
-              <a:buNone/>
-              <a:defRPr sz="750"/>
+            <a:lvl8pPr marL="2268123" indent="0">
+              <a:buNone/>
+              <a:defRPr sz="709"/>
             </a:lvl8pPr>
-            <a:lvl9pPr marL="2743200" indent="0">
-              <a:buNone/>
-              <a:defRPr sz="750"/>
+            <a:lvl9pPr marL="2592141" indent="0">
+              <a:buNone/>
+              <a:defRPr sz="709"/>
             </a:lvl9pPr>
           </a:lstStyle>
           <a:p>
@@ -2091,7 +2096,7 @@
           <a:p>
             <a:fld id="{34E58144-06BA-FC41-A5E7-C2DF4DBA87D5}" type="datetimeFigureOut">
               <a:rPr lang="en-US" smtClean="0"/>
-              <a:t>3/31/23</a:t>
+              <a:t>7/28/23</a:t>
             </a:fld>
             <a:endParaRPr lang="en-US"/>
           </a:p>
@@ -2142,7 +2147,7 @@
     </p:spTree>
     <p:extLst>
       <p:ext uri="{BB962C8B-B14F-4D97-AF65-F5344CB8AC3E}">
-        <p14:creationId xmlns:p14="http://schemas.microsoft.com/office/powerpoint/2010/main" val="627615962"/>
+        <p14:creationId xmlns:p14="http://schemas.microsoft.com/office/powerpoint/2010/main" val="3048791740"/>
       </p:ext>
     </p:extLst>
   </p:cSld>
@@ -2181,15 +2186,15 @@
         </p:nvSpPr>
         <p:spPr>
           <a:xfrm>
-            <a:off x="472381" y="527156"/>
-            <a:ext cx="2211884" cy="1845046"/>
+            <a:off x="446356" y="432012"/>
+            <a:ext cx="2090025" cy="1512041"/>
           </a:xfrm>
         </p:spPr>
         <p:txBody>
           <a:bodyPr anchor="b"/>
           <a:lstStyle>
             <a:lvl1pPr>
-              <a:defRPr sz="2400"/>
+              <a:defRPr sz="2268"/>
             </a:lvl1pPr>
           </a:lstStyle>
           <a:p>
@@ -2213,8 +2218,8 @@
         </p:nvSpPr>
         <p:spPr>
           <a:xfrm>
-            <a:off x="2915543" y="1138512"/>
-            <a:ext cx="3471863" cy="5619335"/>
+            <a:off x="2754918" y="933027"/>
+            <a:ext cx="3280589" cy="4605124"/>
           </a:xfrm>
         </p:spPr>
         <p:txBody>
@@ -2222,39 +2227,39 @@
           <a:lstStyle>
             <a:lvl1pPr marL="0" indent="0">
               <a:buNone/>
-              <a:defRPr sz="2400"/>
+              <a:defRPr sz="2268"/>
             </a:lvl1pPr>
-            <a:lvl2pPr marL="342900" indent="0">
-              <a:buNone/>
-              <a:defRPr sz="2100"/>
+            <a:lvl2pPr marL="324018" indent="0">
+              <a:buNone/>
+              <a:defRPr sz="1984"/>
             </a:lvl2pPr>
-            <a:lvl3pPr marL="685800" indent="0">
-              <a:buNone/>
-              <a:defRPr sz="1800"/>
+            <a:lvl3pPr marL="648035" indent="0">
+              <a:buNone/>
+              <a:defRPr sz="1701"/>
             </a:lvl3pPr>
-            <a:lvl4pPr marL="1028700" indent="0">
-              <a:buNone/>
-              <a:defRPr sz="1500"/>
+            <a:lvl4pPr marL="972053" indent="0">
+              <a:buNone/>
+              <a:defRPr sz="1417"/>
             </a:lvl4pPr>
-            <a:lvl5pPr marL="1371600" indent="0">
-              <a:buNone/>
-              <a:defRPr sz="1500"/>
+            <a:lvl5pPr marL="1296071" indent="0">
+              <a:buNone/>
+              <a:defRPr sz="1417"/>
             </a:lvl5pPr>
-            <a:lvl6pPr marL="1714500" indent="0">
-              <a:buNone/>
-              <a:defRPr sz="1500"/>
+            <a:lvl6pPr marL="1620088" indent="0">
+              <a:buNone/>
+              <a:defRPr sz="1417"/>
             </a:lvl6pPr>
-            <a:lvl7pPr marL="2057400" indent="0">
-              <a:buNone/>
-              <a:defRPr sz="1500"/>
+            <a:lvl7pPr marL="1944106" indent="0">
+              <a:buNone/>
+              <a:defRPr sz="1417"/>
             </a:lvl7pPr>
-            <a:lvl8pPr marL="2400300" indent="0">
-              <a:buNone/>
-              <a:defRPr sz="1500"/>
+            <a:lvl8pPr marL="2268123" indent="0">
+              <a:buNone/>
+              <a:defRPr sz="1417"/>
             </a:lvl8pPr>
-            <a:lvl9pPr marL="2743200" indent="0">
-              <a:buNone/>
-              <a:defRPr sz="1500"/>
+            <a:lvl9pPr marL="2592141" indent="0">
+              <a:buNone/>
+              <a:defRPr sz="1417"/>
             </a:lvl9pPr>
           </a:lstStyle>
           <a:p>
@@ -2278,8 +2283,8 @@
         </p:nvSpPr>
         <p:spPr>
           <a:xfrm>
-            <a:off x="472381" y="2372201"/>
-            <a:ext cx="2211884" cy="4394797"/>
+            <a:off x="446356" y="1944052"/>
+            <a:ext cx="2090025" cy="3601598"/>
           </a:xfrm>
         </p:spPr>
         <p:txBody>
@@ -2287,39 +2292,39 @@
           <a:lstStyle>
             <a:lvl1pPr marL="0" indent="0">
               <a:buNone/>
-              <a:defRPr sz="1200"/>
+              <a:defRPr sz="1134"/>
             </a:lvl1pPr>
-            <a:lvl2pPr marL="342900" indent="0">
-              <a:buNone/>
-              <a:defRPr sz="1050"/>
+            <a:lvl2pPr marL="324018" indent="0">
+              <a:buNone/>
+              <a:defRPr sz="992"/>
             </a:lvl2pPr>
-            <a:lvl3pPr marL="685800" indent="0">
-              <a:buNone/>
-              <a:defRPr sz="900"/>
+            <a:lvl3pPr marL="648035" indent="0">
+              <a:buNone/>
+              <a:defRPr sz="850"/>
             </a:lvl3pPr>
-            <a:lvl4pPr marL="1028700" indent="0">
-              <a:buNone/>
-              <a:defRPr sz="750"/>
+            <a:lvl4pPr marL="972053" indent="0">
+              <a:buNone/>
+              <a:defRPr sz="709"/>
             </a:lvl4pPr>
-            <a:lvl5pPr marL="1371600" indent="0">
-              <a:buNone/>
-              <a:defRPr sz="750"/>
+            <a:lvl5pPr marL="1296071" indent="0">
+              <a:buNone/>
+              <a:defRPr sz="709"/>
             </a:lvl5pPr>
-            <a:lvl6pPr marL="1714500" indent="0">
-              <a:buNone/>
-              <a:defRPr sz="750"/>
+            <a:lvl6pPr marL="1620088" indent="0">
+              <a:buNone/>
+              <a:defRPr sz="709"/>
             </a:lvl6pPr>
-            <a:lvl7pPr marL="2057400" indent="0">
-              <a:buNone/>
-              <a:defRPr sz="750"/>
+            <a:lvl7pPr marL="1944106" indent="0">
+              <a:buNone/>
+              <a:defRPr sz="709"/>
             </a:lvl7pPr>
-            <a:lvl8pPr marL="2400300" indent="0">
-              <a:buNone/>
-              <a:defRPr sz="750"/>
+            <a:lvl8pPr marL="2268123" indent="0">
+              <a:buNone/>
+              <a:defRPr sz="709"/>
             </a:lvl8pPr>
-            <a:lvl9pPr marL="2743200" indent="0">
-              <a:buNone/>
-              <a:defRPr sz="750"/>
+            <a:lvl9pPr marL="2592141" indent="0">
+              <a:buNone/>
+              <a:defRPr sz="709"/>
             </a:lvl9pPr>
           </a:lstStyle>
           <a:p>
@@ -2348,7 +2353,7 @@
           <a:p>
             <a:fld id="{34E58144-06BA-FC41-A5E7-C2DF4DBA87D5}" type="datetimeFigureOut">
               <a:rPr lang="en-US" smtClean="0"/>
-              <a:t>3/31/23</a:t>
+              <a:t>7/28/23</a:t>
             </a:fld>
             <a:endParaRPr lang="en-US"/>
           </a:p>
@@ -2399,7 +2404,7 @@
     </p:spTree>
     <p:extLst>
       <p:ext uri="{BB962C8B-B14F-4D97-AF65-F5344CB8AC3E}">
-        <p14:creationId xmlns:p14="http://schemas.microsoft.com/office/powerpoint/2010/main" val="1142086388"/>
+        <p14:creationId xmlns:p14="http://schemas.microsoft.com/office/powerpoint/2010/main" val="2188236453"/>
       </p:ext>
     </p:extLst>
   </p:cSld>
@@ -2443,8 +2448,8 @@
         </p:nvSpPr>
         <p:spPr>
           <a:xfrm>
-            <a:off x="471488" y="420994"/>
-            <a:ext cx="5915025" cy="1528387"/>
+            <a:off x="445512" y="345011"/>
+            <a:ext cx="5589151" cy="1252534"/>
           </a:xfrm>
           <a:prstGeom prst="rect">
             <a:avLst/>
@@ -2476,8 +2481,8 @@
         </p:nvSpPr>
         <p:spPr>
           <a:xfrm>
-            <a:off x="471488" y="2104963"/>
-            <a:ext cx="5915025" cy="5017133"/>
+            <a:off x="445512" y="1725046"/>
+            <a:ext cx="5589151" cy="4111612"/>
           </a:xfrm>
           <a:prstGeom prst="rect">
             <a:avLst/>
@@ -2538,8 +2543,8 @@
         </p:nvSpPr>
         <p:spPr>
           <a:xfrm>
-            <a:off x="471488" y="7328932"/>
-            <a:ext cx="1543050" cy="420993"/>
+            <a:off x="445512" y="6006164"/>
+            <a:ext cx="1458039" cy="345009"/>
           </a:xfrm>
           <a:prstGeom prst="rect">
             <a:avLst/>
@@ -2549,7 +2554,7 @@
           <a:bodyPr vert="horz" lIns="91440" tIns="45720" rIns="91440" bIns="45720" rtlCol="0" anchor="ctr"/>
           <a:lstStyle>
             <a:lvl1pPr algn="l">
-              <a:defRPr sz="900">
+              <a:defRPr sz="850">
                 <a:solidFill>
                   <a:schemeClr val="tx1">
                     <a:tint val="75000"/>
@@ -2561,7 +2566,7 @@
           <a:p>
             <a:fld id="{34E58144-06BA-FC41-A5E7-C2DF4DBA87D5}" type="datetimeFigureOut">
               <a:rPr lang="en-US" smtClean="0"/>
-              <a:t>3/31/23</a:t>
+              <a:t>7/28/23</a:t>
             </a:fld>
             <a:endParaRPr lang="en-US"/>
           </a:p>
@@ -2579,8 +2584,8 @@
         </p:nvSpPr>
         <p:spPr>
           <a:xfrm>
-            <a:off x="2271713" y="7328932"/>
-            <a:ext cx="2314575" cy="420993"/>
+            <a:off x="2146558" y="6006164"/>
+            <a:ext cx="2187059" cy="345009"/>
           </a:xfrm>
           <a:prstGeom prst="rect">
             <a:avLst/>
@@ -2590,7 +2595,7 @@
           <a:bodyPr vert="horz" lIns="91440" tIns="45720" rIns="91440" bIns="45720" rtlCol="0" anchor="ctr"/>
           <a:lstStyle>
             <a:lvl1pPr algn="ctr">
-              <a:defRPr sz="900">
+              <a:defRPr sz="850">
                 <a:solidFill>
                   <a:schemeClr val="tx1">
                     <a:tint val="75000"/>
@@ -2616,8 +2621,8 @@
         </p:nvSpPr>
         <p:spPr>
           <a:xfrm>
-            <a:off x="4843463" y="7328932"/>
-            <a:ext cx="1543050" cy="420993"/>
+            <a:off x="4576624" y="6006164"/>
+            <a:ext cx="1458039" cy="345009"/>
           </a:xfrm>
           <a:prstGeom prst="rect">
             <a:avLst/>
@@ -2627,7 +2632,7 @@
           <a:bodyPr vert="horz" lIns="91440" tIns="45720" rIns="91440" bIns="45720" rtlCol="0" anchor="ctr"/>
           <a:lstStyle>
             <a:lvl1pPr algn="r">
-              <a:defRPr sz="900">
+              <a:defRPr sz="850">
                 <a:solidFill>
                   <a:schemeClr val="tx1">
                     <a:tint val="75000"/>
@@ -2648,27 +2653,27 @@
     </p:spTree>
     <p:extLst>
       <p:ext uri="{BB962C8B-B14F-4D97-AF65-F5344CB8AC3E}">
-        <p14:creationId xmlns:p14="http://schemas.microsoft.com/office/powerpoint/2010/main" val="2365168587"/>
+        <p14:creationId xmlns:p14="http://schemas.microsoft.com/office/powerpoint/2010/main" val="2771620924"/>
       </p:ext>
     </p:extLst>
   </p:cSld>
   <p:clrMap bg1="lt1" tx1="dk1" bg2="lt2" tx2="dk2" accent1="accent1" accent2="accent2" accent3="accent3" accent4="accent4" accent5="accent5" accent6="accent6" hlink="hlink" folHlink="folHlink"/>
   <p:sldLayoutIdLst>
-    <p:sldLayoutId id="2147483733" r:id="rId1"/>
-    <p:sldLayoutId id="2147483734" r:id="rId2"/>
-    <p:sldLayoutId id="2147483735" r:id="rId3"/>
-    <p:sldLayoutId id="2147483736" r:id="rId4"/>
-    <p:sldLayoutId id="2147483737" r:id="rId5"/>
-    <p:sldLayoutId id="2147483738" r:id="rId6"/>
-    <p:sldLayoutId id="2147483739" r:id="rId7"/>
-    <p:sldLayoutId id="2147483740" r:id="rId8"/>
-    <p:sldLayoutId id="2147483741" r:id="rId9"/>
-    <p:sldLayoutId id="2147483742" r:id="rId10"/>
-    <p:sldLayoutId id="2147483743" r:id="rId11"/>
+    <p:sldLayoutId id="2147483757" r:id="rId1"/>
+    <p:sldLayoutId id="2147483758" r:id="rId2"/>
+    <p:sldLayoutId id="2147483759" r:id="rId3"/>
+    <p:sldLayoutId id="2147483760" r:id="rId4"/>
+    <p:sldLayoutId id="2147483761" r:id="rId5"/>
+    <p:sldLayoutId id="2147483762" r:id="rId6"/>
+    <p:sldLayoutId id="2147483763" r:id="rId7"/>
+    <p:sldLayoutId id="2147483764" r:id="rId8"/>
+    <p:sldLayoutId id="2147483765" r:id="rId9"/>
+    <p:sldLayoutId id="2147483766" r:id="rId10"/>
+    <p:sldLayoutId id="2147483767" r:id="rId11"/>
   </p:sldLayoutIdLst>
   <p:txStyles>
     <p:titleStyle>
-      <a:lvl1pPr algn="l" defTabSz="685800" rtl="0" eaLnBrk="1" latinLnBrk="0" hangingPunct="1">
+      <a:lvl1pPr algn="l" defTabSz="648035" rtl="0" eaLnBrk="1" latinLnBrk="0" hangingPunct="1">
         <a:lnSpc>
           <a:spcPct val="90000"/>
         </a:lnSpc>
@@ -2676,7 +2681,7 @@
           <a:spcPct val="0"/>
         </a:spcBef>
         <a:buNone/>
-        <a:defRPr sz="3300" kern="1200">
+        <a:defRPr sz="3118" kern="1200">
           <a:solidFill>
             <a:schemeClr val="tx1"/>
           </a:solidFill>
@@ -2687,16 +2692,16 @@
       </a:lvl1pPr>
     </p:titleStyle>
     <p:bodyStyle>
-      <a:lvl1pPr marL="171450" indent="-171450" algn="l" defTabSz="685800" rtl="0" eaLnBrk="1" latinLnBrk="0" hangingPunct="1">
+      <a:lvl1pPr marL="162009" indent="-162009" algn="l" defTabSz="648035" rtl="0" eaLnBrk="1" latinLnBrk="0" hangingPunct="1">
         <a:lnSpc>
           <a:spcPct val="90000"/>
         </a:lnSpc>
         <a:spcBef>
-          <a:spcPts val="750"/>
+          <a:spcPts val="709"/>
         </a:spcBef>
         <a:buFont typeface="Arial" panose="020B0604020202020204" pitchFamily="34" charset="0"/>
         <a:buChar char="•"/>
-        <a:defRPr sz="2100" kern="1200">
+        <a:defRPr sz="1984" kern="1200">
           <a:solidFill>
             <a:schemeClr val="tx1"/>
           </a:solidFill>
@@ -2705,16 +2710,16 @@
           <a:cs typeface="+mn-cs"/>
         </a:defRPr>
       </a:lvl1pPr>
-      <a:lvl2pPr marL="514350" indent="-171450" algn="l" defTabSz="685800" rtl="0" eaLnBrk="1" latinLnBrk="0" hangingPunct="1">
+      <a:lvl2pPr marL="486026" indent="-162009" algn="l" defTabSz="648035" rtl="0" eaLnBrk="1" latinLnBrk="0" hangingPunct="1">
         <a:lnSpc>
           <a:spcPct val="90000"/>
         </a:lnSpc>
         <a:spcBef>
-          <a:spcPts val="375"/>
+          <a:spcPts val="354"/>
         </a:spcBef>
         <a:buFont typeface="Arial" panose="020B0604020202020204" pitchFamily="34" charset="0"/>
         <a:buChar char="•"/>
-        <a:defRPr sz="1800" kern="1200">
+        <a:defRPr sz="1701" kern="1200">
           <a:solidFill>
             <a:schemeClr val="tx1"/>
           </a:solidFill>
@@ -2723,16 +2728,16 @@
           <a:cs typeface="+mn-cs"/>
         </a:defRPr>
       </a:lvl2pPr>
-      <a:lvl3pPr marL="857250" indent="-171450" algn="l" defTabSz="685800" rtl="0" eaLnBrk="1" latinLnBrk="0" hangingPunct="1">
+      <a:lvl3pPr marL="810044" indent="-162009" algn="l" defTabSz="648035" rtl="0" eaLnBrk="1" latinLnBrk="0" hangingPunct="1">
         <a:lnSpc>
           <a:spcPct val="90000"/>
         </a:lnSpc>
         <a:spcBef>
-          <a:spcPts val="375"/>
+          <a:spcPts val="354"/>
         </a:spcBef>
         <a:buFont typeface="Arial" panose="020B0604020202020204" pitchFamily="34" charset="0"/>
         <a:buChar char="•"/>
-        <a:defRPr sz="1500" kern="1200">
+        <a:defRPr sz="1417" kern="1200">
           <a:solidFill>
             <a:schemeClr val="tx1"/>
           </a:solidFill>
@@ -2741,16 +2746,16 @@
           <a:cs typeface="+mn-cs"/>
         </a:defRPr>
       </a:lvl3pPr>
-      <a:lvl4pPr marL="1200150" indent="-171450" algn="l" defTabSz="685800" rtl="0" eaLnBrk="1" latinLnBrk="0" hangingPunct="1">
+      <a:lvl4pPr marL="1134062" indent="-162009" algn="l" defTabSz="648035" rtl="0" eaLnBrk="1" latinLnBrk="0" hangingPunct="1">
         <a:lnSpc>
           <a:spcPct val="90000"/>
         </a:lnSpc>
         <a:spcBef>
-          <a:spcPts val="375"/>
+          <a:spcPts val="354"/>
         </a:spcBef>
         <a:buFont typeface="Arial" panose="020B0604020202020204" pitchFamily="34" charset="0"/>
         <a:buChar char="•"/>
-        <a:defRPr sz="1350" kern="1200">
+        <a:defRPr sz="1276" kern="1200">
           <a:solidFill>
             <a:schemeClr val="tx1"/>
           </a:solidFill>
@@ -2759,16 +2764,16 @@
           <a:cs typeface="+mn-cs"/>
         </a:defRPr>
       </a:lvl4pPr>
-      <a:lvl5pPr marL="1543050" indent="-171450" algn="l" defTabSz="685800" rtl="0" eaLnBrk="1" latinLnBrk="0" hangingPunct="1">
+      <a:lvl5pPr marL="1458079" indent="-162009" algn="l" defTabSz="648035" rtl="0" eaLnBrk="1" latinLnBrk="0" hangingPunct="1">
         <a:lnSpc>
           <a:spcPct val="90000"/>
         </a:lnSpc>
         <a:spcBef>
-          <a:spcPts val="375"/>
+          <a:spcPts val="354"/>
         </a:spcBef>
         <a:buFont typeface="Arial" panose="020B0604020202020204" pitchFamily="34" charset="0"/>
         <a:buChar char="•"/>
-        <a:defRPr sz="1350" kern="1200">
+        <a:defRPr sz="1276" kern="1200">
           <a:solidFill>
             <a:schemeClr val="tx1"/>
           </a:solidFill>
@@ -2777,16 +2782,16 @@
           <a:cs typeface="+mn-cs"/>
         </a:defRPr>
       </a:lvl5pPr>
-      <a:lvl6pPr marL="1885950" indent="-171450" algn="l" defTabSz="685800" rtl="0" eaLnBrk="1" latinLnBrk="0" hangingPunct="1">
+      <a:lvl6pPr marL="1782097" indent="-162009" algn="l" defTabSz="648035" rtl="0" eaLnBrk="1" latinLnBrk="0" hangingPunct="1">
         <a:lnSpc>
           <a:spcPct val="90000"/>
         </a:lnSpc>
         <a:spcBef>
-          <a:spcPts val="375"/>
+          <a:spcPts val="354"/>
         </a:spcBef>
         <a:buFont typeface="Arial" panose="020B0604020202020204" pitchFamily="34" charset="0"/>
         <a:buChar char="•"/>
-        <a:defRPr sz="1350" kern="1200">
+        <a:defRPr sz="1276" kern="1200">
           <a:solidFill>
             <a:schemeClr val="tx1"/>
           </a:solidFill>
@@ -2795,16 +2800,16 @@
           <a:cs typeface="+mn-cs"/>
         </a:defRPr>
       </a:lvl6pPr>
-      <a:lvl7pPr marL="2228850" indent="-171450" algn="l" defTabSz="685800" rtl="0" eaLnBrk="1" latinLnBrk="0" hangingPunct="1">
+      <a:lvl7pPr marL="2106115" indent="-162009" algn="l" defTabSz="648035" rtl="0" eaLnBrk="1" latinLnBrk="0" hangingPunct="1">
         <a:lnSpc>
           <a:spcPct val="90000"/>
         </a:lnSpc>
         <a:spcBef>
-          <a:spcPts val="375"/>
+          <a:spcPts val="354"/>
         </a:spcBef>
         <a:buFont typeface="Arial" panose="020B0604020202020204" pitchFamily="34" charset="0"/>
         <a:buChar char="•"/>
-        <a:defRPr sz="1350" kern="1200">
+        <a:defRPr sz="1276" kern="1200">
           <a:solidFill>
             <a:schemeClr val="tx1"/>
           </a:solidFill>
@@ -2813,16 +2818,16 @@
           <a:cs typeface="+mn-cs"/>
         </a:defRPr>
       </a:lvl7pPr>
-      <a:lvl8pPr marL="2571750" indent="-171450" algn="l" defTabSz="685800" rtl="0" eaLnBrk="1" latinLnBrk="0" hangingPunct="1">
+      <a:lvl8pPr marL="2430132" indent="-162009" algn="l" defTabSz="648035" rtl="0" eaLnBrk="1" latinLnBrk="0" hangingPunct="1">
         <a:lnSpc>
           <a:spcPct val="90000"/>
         </a:lnSpc>
         <a:spcBef>
-          <a:spcPts val="375"/>
+          <a:spcPts val="354"/>
         </a:spcBef>
         <a:buFont typeface="Arial" panose="020B0604020202020204" pitchFamily="34" charset="0"/>
         <a:buChar char="•"/>
-        <a:defRPr sz="1350" kern="1200">
+        <a:defRPr sz="1276" kern="1200">
           <a:solidFill>
             <a:schemeClr val="tx1"/>
           </a:solidFill>
@@ -2831,16 +2836,16 @@
           <a:cs typeface="+mn-cs"/>
         </a:defRPr>
       </a:lvl8pPr>
-      <a:lvl9pPr marL="2914650" indent="-171450" algn="l" defTabSz="685800" rtl="0" eaLnBrk="1" latinLnBrk="0" hangingPunct="1">
+      <a:lvl9pPr marL="2754150" indent="-162009" algn="l" defTabSz="648035" rtl="0" eaLnBrk="1" latinLnBrk="0" hangingPunct="1">
         <a:lnSpc>
           <a:spcPct val="90000"/>
         </a:lnSpc>
         <a:spcBef>
-          <a:spcPts val="375"/>
+          <a:spcPts val="354"/>
         </a:spcBef>
         <a:buFont typeface="Arial" panose="020B0604020202020204" pitchFamily="34" charset="0"/>
         <a:buChar char="•"/>
-        <a:defRPr sz="1350" kern="1200">
+        <a:defRPr sz="1276" kern="1200">
           <a:solidFill>
             <a:schemeClr val="tx1"/>
           </a:solidFill>
@@ -2854,8 +2859,8 @@
       <a:defPPr>
         <a:defRPr lang="en-US"/>
       </a:defPPr>
-      <a:lvl1pPr marL="0" algn="l" defTabSz="685800" rtl="0" eaLnBrk="1" latinLnBrk="0" hangingPunct="1">
-        <a:defRPr sz="1350" kern="1200">
+      <a:lvl1pPr marL="0" algn="l" defTabSz="648035" rtl="0" eaLnBrk="1" latinLnBrk="0" hangingPunct="1">
+        <a:defRPr sz="1276" kern="1200">
           <a:solidFill>
             <a:schemeClr val="tx1"/>
           </a:solidFill>
@@ -2864,8 +2869,8 @@
           <a:cs typeface="+mn-cs"/>
         </a:defRPr>
       </a:lvl1pPr>
-      <a:lvl2pPr marL="342900" algn="l" defTabSz="685800" rtl="0" eaLnBrk="1" latinLnBrk="0" hangingPunct="1">
-        <a:defRPr sz="1350" kern="1200">
+      <a:lvl2pPr marL="324018" algn="l" defTabSz="648035" rtl="0" eaLnBrk="1" latinLnBrk="0" hangingPunct="1">
+        <a:defRPr sz="1276" kern="1200">
           <a:solidFill>
             <a:schemeClr val="tx1"/>
           </a:solidFill>
@@ -2874,8 +2879,8 @@
           <a:cs typeface="+mn-cs"/>
         </a:defRPr>
       </a:lvl2pPr>
-      <a:lvl3pPr marL="685800" algn="l" defTabSz="685800" rtl="0" eaLnBrk="1" latinLnBrk="0" hangingPunct="1">
-        <a:defRPr sz="1350" kern="1200">
+      <a:lvl3pPr marL="648035" algn="l" defTabSz="648035" rtl="0" eaLnBrk="1" latinLnBrk="0" hangingPunct="1">
+        <a:defRPr sz="1276" kern="1200">
           <a:solidFill>
             <a:schemeClr val="tx1"/>
           </a:solidFill>
@@ -2884,8 +2889,8 @@
           <a:cs typeface="+mn-cs"/>
         </a:defRPr>
       </a:lvl3pPr>
-      <a:lvl4pPr marL="1028700" algn="l" defTabSz="685800" rtl="0" eaLnBrk="1" latinLnBrk="0" hangingPunct="1">
-        <a:defRPr sz="1350" kern="1200">
+      <a:lvl4pPr marL="972053" algn="l" defTabSz="648035" rtl="0" eaLnBrk="1" latinLnBrk="0" hangingPunct="1">
+        <a:defRPr sz="1276" kern="1200">
           <a:solidFill>
             <a:schemeClr val="tx1"/>
           </a:solidFill>
@@ -2894,8 +2899,8 @@
           <a:cs typeface="+mn-cs"/>
         </a:defRPr>
       </a:lvl4pPr>
-      <a:lvl5pPr marL="1371600" algn="l" defTabSz="685800" rtl="0" eaLnBrk="1" latinLnBrk="0" hangingPunct="1">
-        <a:defRPr sz="1350" kern="1200">
+      <a:lvl5pPr marL="1296071" algn="l" defTabSz="648035" rtl="0" eaLnBrk="1" latinLnBrk="0" hangingPunct="1">
+        <a:defRPr sz="1276" kern="1200">
           <a:solidFill>
             <a:schemeClr val="tx1"/>
           </a:solidFill>
@@ -2904,8 +2909,8 @@
           <a:cs typeface="+mn-cs"/>
         </a:defRPr>
       </a:lvl5pPr>
-      <a:lvl6pPr marL="1714500" algn="l" defTabSz="685800" rtl="0" eaLnBrk="1" latinLnBrk="0" hangingPunct="1">
-        <a:defRPr sz="1350" kern="1200">
+      <a:lvl6pPr marL="1620088" algn="l" defTabSz="648035" rtl="0" eaLnBrk="1" latinLnBrk="0" hangingPunct="1">
+        <a:defRPr sz="1276" kern="1200">
           <a:solidFill>
             <a:schemeClr val="tx1"/>
           </a:solidFill>
@@ -2914,8 +2919,8 @@
           <a:cs typeface="+mn-cs"/>
         </a:defRPr>
       </a:lvl6pPr>
-      <a:lvl7pPr marL="2057400" algn="l" defTabSz="685800" rtl="0" eaLnBrk="1" latinLnBrk="0" hangingPunct="1">
-        <a:defRPr sz="1350" kern="1200">
+      <a:lvl7pPr marL="1944106" algn="l" defTabSz="648035" rtl="0" eaLnBrk="1" latinLnBrk="0" hangingPunct="1">
+        <a:defRPr sz="1276" kern="1200">
           <a:solidFill>
             <a:schemeClr val="tx1"/>
           </a:solidFill>
@@ -2924,8 +2929,8 @@
           <a:cs typeface="+mn-cs"/>
         </a:defRPr>
       </a:lvl7pPr>
-      <a:lvl8pPr marL="2400300" algn="l" defTabSz="685800" rtl="0" eaLnBrk="1" latinLnBrk="0" hangingPunct="1">
-        <a:defRPr sz="1350" kern="1200">
+      <a:lvl8pPr marL="2268123" algn="l" defTabSz="648035" rtl="0" eaLnBrk="1" latinLnBrk="0" hangingPunct="1">
+        <a:defRPr sz="1276" kern="1200">
           <a:solidFill>
             <a:schemeClr val="tx1"/>
           </a:solidFill>
@@ -2934,8 +2939,8 @@
           <a:cs typeface="+mn-cs"/>
         </a:defRPr>
       </a:lvl8pPr>
-      <a:lvl9pPr marL="2743200" algn="l" defTabSz="685800" rtl="0" eaLnBrk="1" latinLnBrk="0" hangingPunct="1">
-        <a:defRPr sz="1350" kern="1200">
+      <a:lvl9pPr marL="2592141" algn="l" defTabSz="648035" rtl="0" eaLnBrk="1" latinLnBrk="0" hangingPunct="1">
+        <a:defRPr sz="1276" kern="1200">
           <a:solidFill>
             <a:schemeClr val="tx1"/>
           </a:solidFill>
@@ -2968,10 +2973,10 @@
       </p:grpSpPr>
       <p:pic>
         <p:nvPicPr>
-          <p:cNvPr id="5" name="Picture 4">
+          <p:cNvPr id="7" name="Picture 6">
             <a:extLst>
               <a:ext uri="{FF2B5EF4-FFF2-40B4-BE49-F238E27FC236}">
-                <a16:creationId xmlns:a16="http://schemas.microsoft.com/office/drawing/2014/main" id="{F294918C-77FD-944D-B26B-1D2F3AD86ADC}"/>
+                <a16:creationId xmlns:a16="http://schemas.microsoft.com/office/drawing/2014/main" id="{B235B9D6-4844-8E4B-A077-E75CD5AA0C34}"/>
               </a:ext>
             </a:extLst>
           </p:cNvPr>
@@ -2988,8 +2993,8 @@
         </p:blipFill>
         <p:spPr>
           <a:xfrm>
-            <a:off x="0" y="3994872"/>
-            <a:ext cx="6858000" cy="3857625"/>
+            <a:off x="0" y="0"/>
+            <a:ext cx="6477000" cy="2743200"/>
           </a:xfrm>
           <a:prstGeom prst="rect">
             <a:avLst/>
@@ -2998,10 +3003,10 @@
       </p:pic>
       <p:pic>
         <p:nvPicPr>
-          <p:cNvPr id="7" name="Picture 6">
+          <p:cNvPr id="11" name="Picture 10">
             <a:extLst>
               <a:ext uri="{FF2B5EF4-FFF2-40B4-BE49-F238E27FC236}">
-                <a16:creationId xmlns:a16="http://schemas.microsoft.com/office/drawing/2014/main" id="{EF4D09AB-75BB-A74A-9196-37D8ACA28BAA}"/>
+                <a16:creationId xmlns:a16="http://schemas.microsoft.com/office/drawing/2014/main" id="{934A2634-4E01-9146-97BE-6321FFAF08EB}"/>
               </a:ext>
             </a:extLst>
           </p:cNvPr>
@@ -3010,15 +3015,16 @@
           </p:cNvPicPr>
           <p:nvPr/>
         </p:nvPicPr>
-        <p:blipFill rotWithShape="1">
+        <p:blipFill>
           <a:blip r:embed="rId3"/>
-          <a:srcRect t="13159" b="15001"/>
-          <a:stretch/>
+          <a:stretch>
+            <a:fillRect/>
+          </a:stretch>
         </p:blipFill>
         <p:spPr>
           <a:xfrm>
-            <a:off x="0" y="20105"/>
-            <a:ext cx="6858000" cy="3962400"/>
+            <a:off x="0" y="2695344"/>
+            <a:ext cx="6477000" cy="3657600"/>
           </a:xfrm>
           <a:prstGeom prst="rect">
             <a:avLst/>
@@ -3027,1721 +3033,10 @@
       </p:pic>
       <p:sp>
         <p:nvSpPr>
-          <p:cNvPr id="8" name="Oval 7">
+          <p:cNvPr id="15" name="TextBox 14">
             <a:extLst>
               <a:ext uri="{FF2B5EF4-FFF2-40B4-BE49-F238E27FC236}">
-                <a16:creationId xmlns:a16="http://schemas.microsoft.com/office/drawing/2014/main" id="{3718F0DD-C193-2946-BB9E-FF3BBC2BD144}"/>
-              </a:ext>
-            </a:extLst>
-          </p:cNvPr>
-          <p:cNvSpPr/>
-          <p:nvPr/>
-        </p:nvSpPr>
-        <p:spPr>
-          <a:xfrm>
-            <a:off x="537689" y="2853197"/>
-            <a:ext cx="69850" cy="76199"/>
-          </a:xfrm>
-          <a:prstGeom prst="ellipse">
-            <a:avLst/>
-          </a:prstGeom>
-          <a:solidFill>
-            <a:srgbClr val="FF0000"/>
-          </a:solidFill>
-          <a:ln>
-            <a:solidFill>
-              <a:schemeClr val="tx1"/>
-            </a:solidFill>
-          </a:ln>
-        </p:spPr>
-        <p:style>
-          <a:lnRef idx="2">
-            <a:schemeClr val="accent1">
-              <a:shade val="50000"/>
-            </a:schemeClr>
-          </a:lnRef>
-          <a:fillRef idx="1">
-            <a:schemeClr val="accent1"/>
-          </a:fillRef>
-          <a:effectRef idx="0">
-            <a:schemeClr val="accent1"/>
-          </a:effectRef>
-          <a:fontRef idx="minor">
-            <a:schemeClr val="lt1"/>
-          </a:fontRef>
-        </p:style>
-        <p:txBody>
-          <a:bodyPr rot="0" spcFirstLastPara="0" vertOverflow="overflow" horzOverflow="overflow" vert="horz" wrap="square" lIns="91440" tIns="45720" rIns="91440" bIns="45720" numCol="1" spcCol="0" rtlCol="0" fromWordArt="0" anchor="ctr" anchorCtr="0" forceAA="0" compatLnSpc="1">
-            <a:prstTxWarp prst="textNoShape">
-              <a:avLst/>
-            </a:prstTxWarp>
-            <a:noAutofit/>
-          </a:bodyPr>
-          <a:lstStyle/>
-          <a:p>
-            <a:pPr algn="ctr"/>
-            <a:endParaRPr lang="en-US"/>
-          </a:p>
-        </p:txBody>
-      </p:sp>
-      <p:sp>
-        <p:nvSpPr>
-          <p:cNvPr id="9" name="Oval 8">
-            <a:extLst>
-              <a:ext uri="{FF2B5EF4-FFF2-40B4-BE49-F238E27FC236}">
-                <a16:creationId xmlns:a16="http://schemas.microsoft.com/office/drawing/2014/main" id="{F5AE6F3B-75AF-2642-85FE-F0135E23640F}"/>
-              </a:ext>
-            </a:extLst>
-          </p:cNvPr>
-          <p:cNvSpPr/>
-          <p:nvPr/>
-        </p:nvSpPr>
-        <p:spPr>
-          <a:xfrm>
-            <a:off x="1716839" y="2183789"/>
-            <a:ext cx="69850" cy="76199"/>
-          </a:xfrm>
-          <a:prstGeom prst="ellipse">
-            <a:avLst/>
-          </a:prstGeom>
-          <a:solidFill>
-            <a:srgbClr val="FF0000"/>
-          </a:solidFill>
-          <a:ln>
-            <a:solidFill>
-              <a:schemeClr val="tx1"/>
-            </a:solidFill>
-          </a:ln>
-        </p:spPr>
-        <p:style>
-          <a:lnRef idx="2">
-            <a:schemeClr val="accent1">
-              <a:shade val="50000"/>
-            </a:schemeClr>
-          </a:lnRef>
-          <a:fillRef idx="1">
-            <a:schemeClr val="accent1"/>
-          </a:fillRef>
-          <a:effectRef idx="0">
-            <a:schemeClr val="accent1"/>
-          </a:effectRef>
-          <a:fontRef idx="minor">
-            <a:schemeClr val="lt1"/>
-          </a:fontRef>
-        </p:style>
-        <p:txBody>
-          <a:bodyPr rot="0" spcFirstLastPara="0" vertOverflow="overflow" horzOverflow="overflow" vert="horz" wrap="square" lIns="91440" tIns="45720" rIns="91440" bIns="45720" numCol="1" spcCol="0" rtlCol="0" fromWordArt="0" anchor="ctr" anchorCtr="0" forceAA="0" compatLnSpc="1">
-            <a:prstTxWarp prst="textNoShape">
-              <a:avLst/>
-            </a:prstTxWarp>
-            <a:noAutofit/>
-          </a:bodyPr>
-          <a:lstStyle/>
-          <a:p>
-            <a:pPr algn="ctr"/>
-            <a:endParaRPr lang="en-US"/>
-          </a:p>
-        </p:txBody>
-      </p:sp>
-      <p:sp>
-        <p:nvSpPr>
-          <p:cNvPr id="10" name="Oval 9">
-            <a:extLst>
-              <a:ext uri="{FF2B5EF4-FFF2-40B4-BE49-F238E27FC236}">
-                <a16:creationId xmlns:a16="http://schemas.microsoft.com/office/drawing/2014/main" id="{2609EA2F-584F-5643-AFE6-EBFE0C3C1A03}"/>
-              </a:ext>
-            </a:extLst>
-          </p:cNvPr>
-          <p:cNvSpPr/>
-          <p:nvPr/>
-        </p:nvSpPr>
-        <p:spPr>
-          <a:xfrm>
-            <a:off x="1952625" y="2055454"/>
-            <a:ext cx="69850" cy="76199"/>
-          </a:xfrm>
-          <a:prstGeom prst="ellipse">
-            <a:avLst/>
-          </a:prstGeom>
-          <a:solidFill>
-            <a:srgbClr val="FF0000"/>
-          </a:solidFill>
-          <a:ln>
-            <a:solidFill>
-              <a:schemeClr val="tx1"/>
-            </a:solidFill>
-          </a:ln>
-        </p:spPr>
-        <p:style>
-          <a:lnRef idx="2">
-            <a:schemeClr val="accent1">
-              <a:shade val="50000"/>
-            </a:schemeClr>
-          </a:lnRef>
-          <a:fillRef idx="1">
-            <a:schemeClr val="accent1"/>
-          </a:fillRef>
-          <a:effectRef idx="0">
-            <a:schemeClr val="accent1"/>
-          </a:effectRef>
-          <a:fontRef idx="minor">
-            <a:schemeClr val="lt1"/>
-          </a:fontRef>
-        </p:style>
-        <p:txBody>
-          <a:bodyPr rot="0" spcFirstLastPara="0" vertOverflow="overflow" horzOverflow="overflow" vert="horz" wrap="square" lIns="91440" tIns="45720" rIns="91440" bIns="45720" numCol="1" spcCol="0" rtlCol="0" fromWordArt="0" anchor="ctr" anchorCtr="0" forceAA="0" compatLnSpc="1">
-            <a:prstTxWarp prst="textNoShape">
-              <a:avLst/>
-            </a:prstTxWarp>
-            <a:noAutofit/>
-          </a:bodyPr>
-          <a:lstStyle/>
-          <a:p>
-            <a:pPr algn="ctr"/>
-            <a:endParaRPr lang="en-US"/>
-          </a:p>
-        </p:txBody>
-      </p:sp>
-      <p:sp>
-        <p:nvSpPr>
-          <p:cNvPr id="11" name="Oval 10">
-            <a:extLst>
-              <a:ext uri="{FF2B5EF4-FFF2-40B4-BE49-F238E27FC236}">
-                <a16:creationId xmlns:a16="http://schemas.microsoft.com/office/drawing/2014/main" id="{1983BEFA-899D-E641-8121-DB9818D11A5C}"/>
-              </a:ext>
-            </a:extLst>
-          </p:cNvPr>
-          <p:cNvSpPr/>
-          <p:nvPr/>
-        </p:nvSpPr>
-        <p:spPr>
-          <a:xfrm>
-            <a:off x="1992396" y="2065480"/>
-            <a:ext cx="69850" cy="76199"/>
-          </a:xfrm>
-          <a:prstGeom prst="ellipse">
-            <a:avLst/>
-          </a:prstGeom>
-          <a:solidFill>
-            <a:srgbClr val="FF0000"/>
-          </a:solidFill>
-          <a:ln>
-            <a:solidFill>
-              <a:schemeClr val="tx1"/>
-            </a:solidFill>
-          </a:ln>
-        </p:spPr>
-        <p:style>
-          <a:lnRef idx="2">
-            <a:schemeClr val="accent1">
-              <a:shade val="50000"/>
-            </a:schemeClr>
-          </a:lnRef>
-          <a:fillRef idx="1">
-            <a:schemeClr val="accent1"/>
-          </a:fillRef>
-          <a:effectRef idx="0">
-            <a:schemeClr val="accent1"/>
-          </a:effectRef>
-          <a:fontRef idx="minor">
-            <a:schemeClr val="lt1"/>
-          </a:fontRef>
-        </p:style>
-        <p:txBody>
-          <a:bodyPr rot="0" spcFirstLastPara="0" vertOverflow="overflow" horzOverflow="overflow" vert="horz" wrap="square" lIns="91440" tIns="45720" rIns="91440" bIns="45720" numCol="1" spcCol="0" rtlCol="0" fromWordArt="0" anchor="ctr" anchorCtr="0" forceAA="0" compatLnSpc="1">
-            <a:prstTxWarp prst="textNoShape">
-              <a:avLst/>
-            </a:prstTxWarp>
-            <a:noAutofit/>
-          </a:bodyPr>
-          <a:lstStyle/>
-          <a:p>
-            <a:pPr algn="ctr"/>
-            <a:endParaRPr lang="en-US"/>
-          </a:p>
-        </p:txBody>
-      </p:sp>
-      <p:sp>
-        <p:nvSpPr>
-          <p:cNvPr id="12" name="Oval 11">
-            <a:extLst>
-              <a:ext uri="{FF2B5EF4-FFF2-40B4-BE49-F238E27FC236}">
-                <a16:creationId xmlns:a16="http://schemas.microsoft.com/office/drawing/2014/main" id="{49295AEA-959D-3149-8287-92847A165954}"/>
-              </a:ext>
-            </a:extLst>
-          </p:cNvPr>
-          <p:cNvSpPr/>
-          <p:nvPr/>
-        </p:nvSpPr>
-        <p:spPr>
-          <a:xfrm>
-            <a:off x="6187198" y="2802191"/>
-            <a:ext cx="69850" cy="76199"/>
-          </a:xfrm>
-          <a:prstGeom prst="ellipse">
-            <a:avLst/>
-          </a:prstGeom>
-          <a:solidFill>
-            <a:srgbClr val="FF0000"/>
-          </a:solidFill>
-          <a:ln>
-            <a:solidFill>
-              <a:schemeClr val="tx1"/>
-            </a:solidFill>
-          </a:ln>
-        </p:spPr>
-        <p:style>
-          <a:lnRef idx="2">
-            <a:schemeClr val="accent1">
-              <a:shade val="50000"/>
-            </a:schemeClr>
-          </a:lnRef>
-          <a:fillRef idx="1">
-            <a:schemeClr val="accent1"/>
-          </a:fillRef>
-          <a:effectRef idx="0">
-            <a:schemeClr val="accent1"/>
-          </a:effectRef>
-          <a:fontRef idx="minor">
-            <a:schemeClr val="lt1"/>
-          </a:fontRef>
-        </p:style>
-        <p:txBody>
-          <a:bodyPr rot="0" spcFirstLastPara="0" vertOverflow="overflow" horzOverflow="overflow" vert="horz" wrap="square" lIns="91440" tIns="45720" rIns="91440" bIns="45720" numCol="1" spcCol="0" rtlCol="0" fromWordArt="0" anchor="ctr" anchorCtr="0" forceAA="0" compatLnSpc="1">
-            <a:prstTxWarp prst="textNoShape">
-              <a:avLst/>
-            </a:prstTxWarp>
-            <a:noAutofit/>
-          </a:bodyPr>
-          <a:lstStyle/>
-          <a:p>
-            <a:pPr algn="ctr"/>
-            <a:endParaRPr lang="en-US"/>
-          </a:p>
-        </p:txBody>
-      </p:sp>
-      <p:sp>
-        <p:nvSpPr>
-          <p:cNvPr id="13" name="Oval 12">
-            <a:extLst>
-              <a:ext uri="{FF2B5EF4-FFF2-40B4-BE49-F238E27FC236}">
-                <a16:creationId xmlns:a16="http://schemas.microsoft.com/office/drawing/2014/main" id="{B7735202-EFAC-F445-9FFC-54D817959DA9}"/>
-              </a:ext>
-            </a:extLst>
-          </p:cNvPr>
-          <p:cNvSpPr/>
-          <p:nvPr/>
-        </p:nvSpPr>
-        <p:spPr>
-          <a:xfrm>
-            <a:off x="6187198" y="2878390"/>
-            <a:ext cx="69850" cy="76199"/>
-          </a:xfrm>
-          <a:prstGeom prst="ellipse">
-            <a:avLst/>
-          </a:prstGeom>
-          <a:solidFill>
-            <a:srgbClr val="FF0000"/>
-          </a:solidFill>
-          <a:ln>
-            <a:solidFill>
-              <a:schemeClr val="tx1"/>
-            </a:solidFill>
-          </a:ln>
-        </p:spPr>
-        <p:style>
-          <a:lnRef idx="2">
-            <a:schemeClr val="accent1">
-              <a:shade val="50000"/>
-            </a:schemeClr>
-          </a:lnRef>
-          <a:fillRef idx="1">
-            <a:schemeClr val="accent1"/>
-          </a:fillRef>
-          <a:effectRef idx="0">
-            <a:schemeClr val="accent1"/>
-          </a:effectRef>
-          <a:fontRef idx="minor">
-            <a:schemeClr val="lt1"/>
-          </a:fontRef>
-        </p:style>
-        <p:txBody>
-          <a:bodyPr rot="0" spcFirstLastPara="0" vertOverflow="overflow" horzOverflow="overflow" vert="horz" wrap="square" lIns="91440" tIns="45720" rIns="91440" bIns="45720" numCol="1" spcCol="0" rtlCol="0" fromWordArt="0" anchor="ctr" anchorCtr="0" forceAA="0" compatLnSpc="1">
-            <a:prstTxWarp prst="textNoShape">
-              <a:avLst/>
-            </a:prstTxWarp>
-            <a:noAutofit/>
-          </a:bodyPr>
-          <a:lstStyle/>
-          <a:p>
-            <a:pPr algn="ctr"/>
-            <a:endParaRPr lang="en-US"/>
-          </a:p>
-        </p:txBody>
-      </p:sp>
-      <p:sp>
-        <p:nvSpPr>
-          <p:cNvPr id="14" name="Oval 13">
-            <a:extLst>
-              <a:ext uri="{FF2B5EF4-FFF2-40B4-BE49-F238E27FC236}">
-                <a16:creationId xmlns:a16="http://schemas.microsoft.com/office/drawing/2014/main" id="{53804A71-3E72-234F-8967-FE7E48019F4F}"/>
-              </a:ext>
-            </a:extLst>
-          </p:cNvPr>
-          <p:cNvSpPr/>
-          <p:nvPr/>
-        </p:nvSpPr>
-        <p:spPr>
-          <a:xfrm>
-            <a:off x="6319116" y="2954589"/>
-            <a:ext cx="69850" cy="76199"/>
-          </a:xfrm>
-          <a:prstGeom prst="ellipse">
-            <a:avLst/>
-          </a:prstGeom>
-          <a:solidFill>
-            <a:srgbClr val="FF0000"/>
-          </a:solidFill>
-          <a:ln>
-            <a:solidFill>
-              <a:schemeClr val="tx1"/>
-            </a:solidFill>
-          </a:ln>
-        </p:spPr>
-        <p:style>
-          <a:lnRef idx="2">
-            <a:schemeClr val="accent1">
-              <a:shade val="50000"/>
-            </a:schemeClr>
-          </a:lnRef>
-          <a:fillRef idx="1">
-            <a:schemeClr val="accent1"/>
-          </a:fillRef>
-          <a:effectRef idx="0">
-            <a:schemeClr val="accent1"/>
-          </a:effectRef>
-          <a:fontRef idx="minor">
-            <a:schemeClr val="lt1"/>
-          </a:fontRef>
-        </p:style>
-        <p:txBody>
-          <a:bodyPr rot="0" spcFirstLastPara="0" vertOverflow="overflow" horzOverflow="overflow" vert="horz" wrap="square" lIns="91440" tIns="45720" rIns="91440" bIns="45720" numCol="1" spcCol="0" rtlCol="0" fromWordArt="0" anchor="ctr" anchorCtr="0" forceAA="0" compatLnSpc="1">
-            <a:prstTxWarp prst="textNoShape">
-              <a:avLst/>
-            </a:prstTxWarp>
-            <a:noAutofit/>
-          </a:bodyPr>
-          <a:lstStyle/>
-          <a:p>
-            <a:pPr algn="ctr"/>
-            <a:endParaRPr lang="en-US"/>
-          </a:p>
-        </p:txBody>
-      </p:sp>
-      <p:sp>
-        <p:nvSpPr>
-          <p:cNvPr id="15" name="Oval 14">
-            <a:extLst>
-              <a:ext uri="{FF2B5EF4-FFF2-40B4-BE49-F238E27FC236}">
-                <a16:creationId xmlns:a16="http://schemas.microsoft.com/office/drawing/2014/main" id="{591F46D1-2EC2-3847-BEF2-B6D30237279C}"/>
-              </a:ext>
-            </a:extLst>
-          </p:cNvPr>
-          <p:cNvSpPr/>
-          <p:nvPr/>
-        </p:nvSpPr>
-        <p:spPr>
-          <a:xfrm>
-            <a:off x="2171159" y="2150010"/>
-            <a:ext cx="69850" cy="76199"/>
-          </a:xfrm>
-          <a:prstGeom prst="ellipse">
-            <a:avLst/>
-          </a:prstGeom>
-          <a:solidFill>
-            <a:srgbClr val="FF0000"/>
-          </a:solidFill>
-          <a:ln>
-            <a:solidFill>
-              <a:schemeClr val="tx1"/>
-            </a:solidFill>
-          </a:ln>
-        </p:spPr>
-        <p:style>
-          <a:lnRef idx="2">
-            <a:schemeClr val="accent1">
-              <a:shade val="50000"/>
-            </a:schemeClr>
-          </a:lnRef>
-          <a:fillRef idx="1">
-            <a:schemeClr val="accent1"/>
-          </a:fillRef>
-          <a:effectRef idx="0">
-            <a:schemeClr val="accent1"/>
-          </a:effectRef>
-          <a:fontRef idx="minor">
-            <a:schemeClr val="lt1"/>
-          </a:fontRef>
-        </p:style>
-        <p:txBody>
-          <a:bodyPr rot="0" spcFirstLastPara="0" vertOverflow="overflow" horzOverflow="overflow" vert="horz" wrap="square" lIns="91440" tIns="45720" rIns="91440" bIns="45720" numCol="1" spcCol="0" rtlCol="0" fromWordArt="0" anchor="ctr" anchorCtr="0" forceAA="0" compatLnSpc="1">
-            <a:prstTxWarp prst="textNoShape">
-              <a:avLst/>
-            </a:prstTxWarp>
-            <a:noAutofit/>
-          </a:bodyPr>
-          <a:lstStyle/>
-          <a:p>
-            <a:pPr algn="ctr"/>
-            <a:endParaRPr lang="en-US"/>
-          </a:p>
-        </p:txBody>
-      </p:sp>
-      <p:sp>
-        <p:nvSpPr>
-          <p:cNvPr id="19" name="Oval 18">
-            <a:extLst>
-              <a:ext uri="{FF2B5EF4-FFF2-40B4-BE49-F238E27FC236}">
-                <a16:creationId xmlns:a16="http://schemas.microsoft.com/office/drawing/2014/main" id="{95C2B4E1-81E0-F244-B9CF-CE2CDC556AA3}"/>
-              </a:ext>
-            </a:extLst>
-          </p:cNvPr>
-          <p:cNvSpPr/>
-          <p:nvPr/>
-        </p:nvSpPr>
-        <p:spPr>
-          <a:xfrm>
-            <a:off x="1999035" y="3341981"/>
-            <a:ext cx="69850" cy="76199"/>
-          </a:xfrm>
-          <a:prstGeom prst="ellipse">
-            <a:avLst/>
-          </a:prstGeom>
-          <a:solidFill>
-            <a:schemeClr val="accent1"/>
-          </a:solidFill>
-          <a:ln>
-            <a:solidFill>
-              <a:schemeClr val="tx1"/>
-            </a:solidFill>
-          </a:ln>
-        </p:spPr>
-        <p:style>
-          <a:lnRef idx="2">
-            <a:schemeClr val="accent1">
-              <a:shade val="50000"/>
-            </a:schemeClr>
-          </a:lnRef>
-          <a:fillRef idx="1">
-            <a:schemeClr val="accent1"/>
-          </a:fillRef>
-          <a:effectRef idx="0">
-            <a:schemeClr val="accent1"/>
-          </a:effectRef>
-          <a:fontRef idx="minor">
-            <a:schemeClr val="lt1"/>
-          </a:fontRef>
-        </p:style>
-        <p:txBody>
-          <a:bodyPr rot="0" spcFirstLastPara="0" vertOverflow="overflow" horzOverflow="overflow" vert="horz" wrap="square" lIns="91440" tIns="45720" rIns="91440" bIns="45720" numCol="1" spcCol="0" rtlCol="0" fromWordArt="0" anchor="ctr" anchorCtr="0" forceAA="0" compatLnSpc="1">
-            <a:prstTxWarp prst="textNoShape">
-              <a:avLst/>
-            </a:prstTxWarp>
-            <a:noAutofit/>
-          </a:bodyPr>
-          <a:lstStyle/>
-          <a:p>
-            <a:pPr algn="ctr"/>
-            <a:endParaRPr lang="en-US"/>
-          </a:p>
-        </p:txBody>
-      </p:sp>
-      <p:sp>
-        <p:nvSpPr>
-          <p:cNvPr id="22" name="Oval 21">
-            <a:extLst>
-              <a:ext uri="{FF2B5EF4-FFF2-40B4-BE49-F238E27FC236}">
-                <a16:creationId xmlns:a16="http://schemas.microsoft.com/office/drawing/2014/main" id="{226E010C-4ADE-9D4B-A978-8FB6E890D402}"/>
-              </a:ext>
-            </a:extLst>
-          </p:cNvPr>
-          <p:cNvSpPr/>
-          <p:nvPr/>
-        </p:nvSpPr>
-        <p:spPr>
-          <a:xfrm>
-            <a:off x="1753077" y="1901358"/>
-            <a:ext cx="69850" cy="76199"/>
-          </a:xfrm>
-          <a:prstGeom prst="ellipse">
-            <a:avLst/>
-          </a:prstGeom>
-          <a:solidFill>
-            <a:schemeClr val="accent2"/>
-          </a:solidFill>
-          <a:ln>
-            <a:solidFill>
-              <a:schemeClr val="tx1"/>
-            </a:solidFill>
-          </a:ln>
-        </p:spPr>
-        <p:style>
-          <a:lnRef idx="2">
-            <a:schemeClr val="accent1">
-              <a:shade val="50000"/>
-            </a:schemeClr>
-          </a:lnRef>
-          <a:fillRef idx="1">
-            <a:schemeClr val="accent1"/>
-          </a:fillRef>
-          <a:effectRef idx="0">
-            <a:schemeClr val="accent1"/>
-          </a:effectRef>
-          <a:fontRef idx="minor">
-            <a:schemeClr val="lt1"/>
-          </a:fontRef>
-        </p:style>
-        <p:txBody>
-          <a:bodyPr rot="0" spcFirstLastPara="0" vertOverflow="overflow" horzOverflow="overflow" vert="horz" wrap="square" lIns="91440" tIns="45720" rIns="91440" bIns="45720" numCol="1" spcCol="0" rtlCol="0" fromWordArt="0" anchor="ctr" anchorCtr="0" forceAA="0" compatLnSpc="1">
-            <a:prstTxWarp prst="textNoShape">
-              <a:avLst/>
-            </a:prstTxWarp>
-            <a:noAutofit/>
-          </a:bodyPr>
-          <a:lstStyle/>
-          <a:p>
-            <a:pPr algn="ctr"/>
-            <a:endParaRPr lang="en-US"/>
-          </a:p>
-        </p:txBody>
-      </p:sp>
-      <p:sp>
-        <p:nvSpPr>
-          <p:cNvPr id="23" name="Oval 22">
-            <a:extLst>
-              <a:ext uri="{FF2B5EF4-FFF2-40B4-BE49-F238E27FC236}">
-                <a16:creationId xmlns:a16="http://schemas.microsoft.com/office/drawing/2014/main" id="{FC226587-C43B-FD47-9F3F-03C4E28F0D92}"/>
-              </a:ext>
-            </a:extLst>
-          </p:cNvPr>
-          <p:cNvSpPr/>
-          <p:nvPr/>
-        </p:nvSpPr>
-        <p:spPr>
-          <a:xfrm>
-            <a:off x="1936969" y="1960726"/>
-            <a:ext cx="69850" cy="76199"/>
-          </a:xfrm>
-          <a:prstGeom prst="ellipse">
-            <a:avLst/>
-          </a:prstGeom>
-          <a:solidFill>
-            <a:schemeClr val="accent2"/>
-          </a:solidFill>
-          <a:ln>
-            <a:solidFill>
-              <a:schemeClr val="tx1"/>
-            </a:solidFill>
-          </a:ln>
-        </p:spPr>
-        <p:style>
-          <a:lnRef idx="2">
-            <a:schemeClr val="accent1">
-              <a:shade val="50000"/>
-            </a:schemeClr>
-          </a:lnRef>
-          <a:fillRef idx="1">
-            <a:schemeClr val="accent1"/>
-          </a:fillRef>
-          <a:effectRef idx="0">
-            <a:schemeClr val="accent1"/>
-          </a:effectRef>
-          <a:fontRef idx="minor">
-            <a:schemeClr val="lt1"/>
-          </a:fontRef>
-        </p:style>
-        <p:txBody>
-          <a:bodyPr rot="0" spcFirstLastPara="0" vertOverflow="overflow" horzOverflow="overflow" vert="horz" wrap="square" lIns="91440" tIns="45720" rIns="91440" bIns="45720" numCol="1" spcCol="0" rtlCol="0" fromWordArt="0" anchor="ctr" anchorCtr="0" forceAA="0" compatLnSpc="1">
-            <a:prstTxWarp prst="textNoShape">
-              <a:avLst/>
-            </a:prstTxWarp>
-            <a:noAutofit/>
-          </a:bodyPr>
-          <a:lstStyle/>
-          <a:p>
-            <a:pPr algn="ctr"/>
-            <a:endParaRPr lang="en-US"/>
-          </a:p>
-        </p:txBody>
-      </p:sp>
-      <p:sp>
-        <p:nvSpPr>
-          <p:cNvPr id="24" name="Oval 23">
-            <a:extLst>
-              <a:ext uri="{FF2B5EF4-FFF2-40B4-BE49-F238E27FC236}">
-                <a16:creationId xmlns:a16="http://schemas.microsoft.com/office/drawing/2014/main" id="{97AFAEF0-2516-5544-A657-ACD0CDA5DC2F}"/>
-              </a:ext>
-            </a:extLst>
-          </p:cNvPr>
-          <p:cNvSpPr/>
-          <p:nvPr/>
-        </p:nvSpPr>
-        <p:spPr>
-          <a:xfrm>
-            <a:off x="1795186" y="2012241"/>
-            <a:ext cx="69850" cy="76199"/>
-          </a:xfrm>
-          <a:prstGeom prst="ellipse">
-            <a:avLst/>
-          </a:prstGeom>
-          <a:solidFill>
-            <a:schemeClr val="accent2"/>
-          </a:solidFill>
-          <a:ln>
-            <a:solidFill>
-              <a:schemeClr val="tx1"/>
-            </a:solidFill>
-          </a:ln>
-        </p:spPr>
-        <p:style>
-          <a:lnRef idx="2">
-            <a:schemeClr val="accent1">
-              <a:shade val="50000"/>
-            </a:schemeClr>
-          </a:lnRef>
-          <a:fillRef idx="1">
-            <a:schemeClr val="accent1"/>
-          </a:fillRef>
-          <a:effectRef idx="0">
-            <a:schemeClr val="accent1"/>
-          </a:effectRef>
-          <a:fontRef idx="minor">
-            <a:schemeClr val="lt1"/>
-          </a:fontRef>
-        </p:style>
-        <p:txBody>
-          <a:bodyPr rot="0" spcFirstLastPara="0" vertOverflow="overflow" horzOverflow="overflow" vert="horz" wrap="square" lIns="91440" tIns="45720" rIns="91440" bIns="45720" numCol="1" spcCol="0" rtlCol="0" fromWordArt="0" anchor="ctr" anchorCtr="0" forceAA="0" compatLnSpc="1">
-            <a:prstTxWarp prst="textNoShape">
-              <a:avLst/>
-            </a:prstTxWarp>
-            <a:noAutofit/>
-          </a:bodyPr>
-          <a:lstStyle/>
-          <a:p>
-            <a:pPr algn="ctr"/>
-            <a:endParaRPr lang="en-US"/>
-          </a:p>
-        </p:txBody>
-      </p:sp>
-      <p:sp>
-        <p:nvSpPr>
-          <p:cNvPr id="25" name="Oval 24">
-            <a:extLst>
-              <a:ext uri="{FF2B5EF4-FFF2-40B4-BE49-F238E27FC236}">
-                <a16:creationId xmlns:a16="http://schemas.microsoft.com/office/drawing/2014/main" id="{D8470AA8-EA5C-F74B-B595-8A3FD6BF7F0A}"/>
-              </a:ext>
-            </a:extLst>
-          </p:cNvPr>
-          <p:cNvSpPr/>
-          <p:nvPr/>
-        </p:nvSpPr>
-        <p:spPr>
-          <a:xfrm>
-            <a:off x="1853018" y="2003115"/>
-            <a:ext cx="69850" cy="76199"/>
-          </a:xfrm>
-          <a:prstGeom prst="ellipse">
-            <a:avLst/>
-          </a:prstGeom>
-          <a:solidFill>
-            <a:schemeClr val="accent2"/>
-          </a:solidFill>
-          <a:ln>
-            <a:solidFill>
-              <a:schemeClr val="tx1"/>
-            </a:solidFill>
-          </a:ln>
-        </p:spPr>
-        <p:style>
-          <a:lnRef idx="2">
-            <a:schemeClr val="accent1">
-              <a:shade val="50000"/>
-            </a:schemeClr>
-          </a:lnRef>
-          <a:fillRef idx="1">
-            <a:schemeClr val="accent1"/>
-          </a:fillRef>
-          <a:effectRef idx="0">
-            <a:schemeClr val="accent1"/>
-          </a:effectRef>
-          <a:fontRef idx="minor">
-            <a:schemeClr val="lt1"/>
-          </a:fontRef>
-        </p:style>
-        <p:txBody>
-          <a:bodyPr rot="0" spcFirstLastPara="0" vertOverflow="overflow" horzOverflow="overflow" vert="horz" wrap="square" lIns="91440" tIns="45720" rIns="91440" bIns="45720" numCol="1" spcCol="0" rtlCol="0" fromWordArt="0" anchor="ctr" anchorCtr="0" forceAA="0" compatLnSpc="1">
-            <a:prstTxWarp prst="textNoShape">
-              <a:avLst/>
-            </a:prstTxWarp>
-            <a:noAutofit/>
-          </a:bodyPr>
-          <a:lstStyle/>
-          <a:p>
-            <a:pPr algn="ctr"/>
-            <a:endParaRPr lang="en-US"/>
-          </a:p>
-        </p:txBody>
-      </p:sp>
-      <p:sp>
-        <p:nvSpPr>
-          <p:cNvPr id="26" name="Oval 25">
-            <a:extLst>
-              <a:ext uri="{FF2B5EF4-FFF2-40B4-BE49-F238E27FC236}">
-                <a16:creationId xmlns:a16="http://schemas.microsoft.com/office/drawing/2014/main" id="{DFAB79DC-2974-C54C-B6B4-36D7AAB47E41}"/>
-              </a:ext>
-            </a:extLst>
-          </p:cNvPr>
-          <p:cNvSpPr/>
-          <p:nvPr/>
-        </p:nvSpPr>
-        <p:spPr>
-          <a:xfrm>
-            <a:off x="1853343" y="1866340"/>
-            <a:ext cx="69850" cy="76199"/>
-          </a:xfrm>
-          <a:prstGeom prst="ellipse">
-            <a:avLst/>
-          </a:prstGeom>
-          <a:solidFill>
-            <a:schemeClr val="accent2"/>
-          </a:solidFill>
-          <a:ln>
-            <a:solidFill>
-              <a:schemeClr val="tx1"/>
-            </a:solidFill>
-          </a:ln>
-        </p:spPr>
-        <p:style>
-          <a:lnRef idx="2">
-            <a:schemeClr val="accent1">
-              <a:shade val="50000"/>
-            </a:schemeClr>
-          </a:lnRef>
-          <a:fillRef idx="1">
-            <a:schemeClr val="accent1"/>
-          </a:fillRef>
-          <a:effectRef idx="0">
-            <a:schemeClr val="accent1"/>
-          </a:effectRef>
-          <a:fontRef idx="minor">
-            <a:schemeClr val="lt1"/>
-          </a:fontRef>
-        </p:style>
-        <p:txBody>
-          <a:bodyPr rot="0" spcFirstLastPara="0" vertOverflow="overflow" horzOverflow="overflow" vert="horz" wrap="square" lIns="91440" tIns="45720" rIns="91440" bIns="45720" numCol="1" spcCol="0" rtlCol="0" fromWordArt="0" anchor="ctr" anchorCtr="0" forceAA="0" compatLnSpc="1">
-            <a:prstTxWarp prst="textNoShape">
-              <a:avLst/>
-            </a:prstTxWarp>
-            <a:noAutofit/>
-          </a:bodyPr>
-          <a:lstStyle/>
-          <a:p>
-            <a:pPr algn="ctr"/>
-            <a:endParaRPr lang="en-US"/>
-          </a:p>
-        </p:txBody>
-      </p:sp>
-      <p:sp>
-        <p:nvSpPr>
-          <p:cNvPr id="27" name="Oval 26">
-            <a:extLst>
-              <a:ext uri="{FF2B5EF4-FFF2-40B4-BE49-F238E27FC236}">
-                <a16:creationId xmlns:a16="http://schemas.microsoft.com/office/drawing/2014/main" id="{5882FCC9-E6A2-984A-96A3-CD89EB5E07CD}"/>
-              </a:ext>
-            </a:extLst>
-          </p:cNvPr>
-          <p:cNvSpPr/>
-          <p:nvPr/>
-        </p:nvSpPr>
-        <p:spPr>
-          <a:xfrm>
-            <a:off x="1940350" y="1792294"/>
-            <a:ext cx="69850" cy="76199"/>
-          </a:xfrm>
-          <a:prstGeom prst="ellipse">
-            <a:avLst/>
-          </a:prstGeom>
-          <a:solidFill>
-            <a:schemeClr val="accent2"/>
-          </a:solidFill>
-          <a:ln>
-            <a:solidFill>
-              <a:schemeClr val="tx1"/>
-            </a:solidFill>
-          </a:ln>
-        </p:spPr>
-        <p:style>
-          <a:lnRef idx="2">
-            <a:schemeClr val="accent1">
-              <a:shade val="50000"/>
-            </a:schemeClr>
-          </a:lnRef>
-          <a:fillRef idx="1">
-            <a:schemeClr val="accent1"/>
-          </a:fillRef>
-          <a:effectRef idx="0">
-            <a:schemeClr val="accent1"/>
-          </a:effectRef>
-          <a:fontRef idx="minor">
-            <a:schemeClr val="lt1"/>
-          </a:fontRef>
-        </p:style>
-        <p:txBody>
-          <a:bodyPr rot="0" spcFirstLastPara="0" vertOverflow="overflow" horzOverflow="overflow" vert="horz" wrap="square" lIns="91440" tIns="45720" rIns="91440" bIns="45720" numCol="1" spcCol="0" rtlCol="0" fromWordArt="0" anchor="ctr" anchorCtr="0" forceAA="0" compatLnSpc="1">
-            <a:prstTxWarp prst="textNoShape">
-              <a:avLst/>
-            </a:prstTxWarp>
-            <a:noAutofit/>
-          </a:bodyPr>
-          <a:lstStyle/>
-          <a:p>
-            <a:pPr algn="ctr"/>
-            <a:endParaRPr lang="en-US"/>
-          </a:p>
-        </p:txBody>
-      </p:sp>
-      <p:sp>
-        <p:nvSpPr>
-          <p:cNvPr id="28" name="Oval 27">
-            <a:extLst>
-              <a:ext uri="{FF2B5EF4-FFF2-40B4-BE49-F238E27FC236}">
-                <a16:creationId xmlns:a16="http://schemas.microsoft.com/office/drawing/2014/main" id="{6F31A02E-A46E-464F-8570-0D2613B81A7C}"/>
-              </a:ext>
-            </a:extLst>
-          </p:cNvPr>
-          <p:cNvSpPr/>
-          <p:nvPr/>
-        </p:nvSpPr>
-        <p:spPr>
-          <a:xfrm>
-            <a:off x="1182709" y="1899482"/>
-            <a:ext cx="69850" cy="76199"/>
-          </a:xfrm>
-          <a:prstGeom prst="ellipse">
-            <a:avLst/>
-          </a:prstGeom>
-          <a:solidFill>
-            <a:schemeClr val="accent2"/>
-          </a:solidFill>
-          <a:ln>
-            <a:solidFill>
-              <a:schemeClr val="tx1"/>
-            </a:solidFill>
-          </a:ln>
-        </p:spPr>
-        <p:style>
-          <a:lnRef idx="2">
-            <a:schemeClr val="accent1">
-              <a:shade val="50000"/>
-            </a:schemeClr>
-          </a:lnRef>
-          <a:fillRef idx="1">
-            <a:schemeClr val="accent1"/>
-          </a:fillRef>
-          <a:effectRef idx="0">
-            <a:schemeClr val="accent1"/>
-          </a:effectRef>
-          <a:fontRef idx="minor">
-            <a:schemeClr val="lt1"/>
-          </a:fontRef>
-        </p:style>
-        <p:txBody>
-          <a:bodyPr rot="0" spcFirstLastPara="0" vertOverflow="overflow" horzOverflow="overflow" vert="horz" wrap="square" lIns="91440" tIns="45720" rIns="91440" bIns="45720" numCol="1" spcCol="0" rtlCol="0" fromWordArt="0" anchor="ctr" anchorCtr="0" forceAA="0" compatLnSpc="1">
-            <a:prstTxWarp prst="textNoShape">
-              <a:avLst/>
-            </a:prstTxWarp>
-            <a:noAutofit/>
-          </a:bodyPr>
-          <a:lstStyle/>
-          <a:p>
-            <a:pPr algn="ctr"/>
-            <a:endParaRPr lang="en-US"/>
-          </a:p>
-        </p:txBody>
-      </p:sp>
-      <p:sp>
-        <p:nvSpPr>
-          <p:cNvPr id="29" name="Oval 28">
-            <a:extLst>
-              <a:ext uri="{FF2B5EF4-FFF2-40B4-BE49-F238E27FC236}">
-                <a16:creationId xmlns:a16="http://schemas.microsoft.com/office/drawing/2014/main" id="{D6FF5096-FCC8-B94F-964A-640C2FA8598F}"/>
-              </a:ext>
-            </a:extLst>
-          </p:cNvPr>
-          <p:cNvSpPr/>
-          <p:nvPr/>
-        </p:nvSpPr>
-        <p:spPr>
-          <a:xfrm>
-            <a:off x="4073366" y="1917435"/>
-            <a:ext cx="69850" cy="76199"/>
-          </a:xfrm>
-          <a:prstGeom prst="ellipse">
-            <a:avLst/>
-          </a:prstGeom>
-          <a:solidFill>
-            <a:schemeClr val="accent2"/>
-          </a:solidFill>
-          <a:ln>
-            <a:solidFill>
-              <a:schemeClr val="tx1"/>
-            </a:solidFill>
-          </a:ln>
-        </p:spPr>
-        <p:style>
-          <a:lnRef idx="2">
-            <a:schemeClr val="accent1">
-              <a:shade val="50000"/>
-            </a:schemeClr>
-          </a:lnRef>
-          <a:fillRef idx="1">
-            <a:schemeClr val="accent1"/>
-          </a:fillRef>
-          <a:effectRef idx="0">
-            <a:schemeClr val="accent1"/>
-          </a:effectRef>
-          <a:fontRef idx="minor">
-            <a:schemeClr val="lt1"/>
-          </a:fontRef>
-        </p:style>
-        <p:txBody>
-          <a:bodyPr rot="0" spcFirstLastPara="0" vertOverflow="overflow" horzOverflow="overflow" vert="horz" wrap="square" lIns="91440" tIns="45720" rIns="91440" bIns="45720" numCol="1" spcCol="0" rtlCol="0" fromWordArt="0" anchor="ctr" anchorCtr="0" forceAA="0" compatLnSpc="1">
-            <a:prstTxWarp prst="textNoShape">
-              <a:avLst/>
-            </a:prstTxWarp>
-            <a:noAutofit/>
-          </a:bodyPr>
-          <a:lstStyle/>
-          <a:p>
-            <a:pPr algn="ctr"/>
-            <a:endParaRPr lang="en-US"/>
-          </a:p>
-        </p:txBody>
-      </p:sp>
-      <p:sp>
-        <p:nvSpPr>
-          <p:cNvPr id="31" name="Oval 30">
-            <a:extLst>
-              <a:ext uri="{FF2B5EF4-FFF2-40B4-BE49-F238E27FC236}">
-                <a16:creationId xmlns:a16="http://schemas.microsoft.com/office/drawing/2014/main" id="{463E226E-711B-C64E-B808-2672CB160D99}"/>
-              </a:ext>
-            </a:extLst>
-          </p:cNvPr>
-          <p:cNvSpPr/>
-          <p:nvPr/>
-        </p:nvSpPr>
-        <p:spPr>
-          <a:xfrm>
-            <a:off x="6344657" y="3145626"/>
-            <a:ext cx="69850" cy="76199"/>
-          </a:xfrm>
-          <a:prstGeom prst="ellipse">
-            <a:avLst/>
-          </a:prstGeom>
-          <a:solidFill>
-            <a:schemeClr val="accent2"/>
-          </a:solidFill>
-          <a:ln>
-            <a:solidFill>
-              <a:schemeClr val="tx1"/>
-            </a:solidFill>
-          </a:ln>
-        </p:spPr>
-        <p:style>
-          <a:lnRef idx="2">
-            <a:schemeClr val="accent1">
-              <a:shade val="50000"/>
-            </a:schemeClr>
-          </a:lnRef>
-          <a:fillRef idx="1">
-            <a:schemeClr val="accent1"/>
-          </a:fillRef>
-          <a:effectRef idx="0">
-            <a:schemeClr val="accent1"/>
-          </a:effectRef>
-          <a:fontRef idx="minor">
-            <a:schemeClr val="lt1"/>
-          </a:fontRef>
-        </p:style>
-        <p:txBody>
-          <a:bodyPr rot="0" spcFirstLastPara="0" vertOverflow="overflow" horzOverflow="overflow" vert="horz" wrap="square" lIns="91440" tIns="45720" rIns="91440" bIns="45720" numCol="1" spcCol="0" rtlCol="0" fromWordArt="0" anchor="ctr" anchorCtr="0" forceAA="0" compatLnSpc="1">
-            <a:prstTxWarp prst="textNoShape">
-              <a:avLst/>
-            </a:prstTxWarp>
-            <a:noAutofit/>
-          </a:bodyPr>
-          <a:lstStyle/>
-          <a:p>
-            <a:pPr algn="ctr"/>
-            <a:endParaRPr lang="en-US"/>
-          </a:p>
-        </p:txBody>
-      </p:sp>
-      <p:sp>
-        <p:nvSpPr>
-          <p:cNvPr id="33" name="Oval 32">
-            <a:extLst>
-              <a:ext uri="{FF2B5EF4-FFF2-40B4-BE49-F238E27FC236}">
-                <a16:creationId xmlns:a16="http://schemas.microsoft.com/office/drawing/2014/main" id="{BBC0D422-6E30-914E-9B2E-1484B95F5B30}"/>
-              </a:ext>
-            </a:extLst>
-          </p:cNvPr>
-          <p:cNvSpPr/>
-          <p:nvPr/>
-        </p:nvSpPr>
-        <p:spPr>
-          <a:xfrm>
-            <a:off x="6668017" y="3491723"/>
-            <a:ext cx="69850" cy="76199"/>
-          </a:xfrm>
-          <a:prstGeom prst="ellipse">
-            <a:avLst/>
-          </a:prstGeom>
-          <a:solidFill>
-            <a:schemeClr val="accent1"/>
-          </a:solidFill>
-          <a:ln>
-            <a:solidFill>
-              <a:schemeClr val="tx1"/>
-            </a:solidFill>
-          </a:ln>
-        </p:spPr>
-        <p:style>
-          <a:lnRef idx="2">
-            <a:schemeClr val="accent1">
-              <a:shade val="50000"/>
-            </a:schemeClr>
-          </a:lnRef>
-          <a:fillRef idx="1">
-            <a:schemeClr val="accent1"/>
-          </a:fillRef>
-          <a:effectRef idx="0">
-            <a:schemeClr val="accent1"/>
-          </a:effectRef>
-          <a:fontRef idx="minor">
-            <a:schemeClr val="lt1"/>
-          </a:fontRef>
-        </p:style>
-        <p:txBody>
-          <a:bodyPr rot="0" spcFirstLastPara="0" vertOverflow="overflow" horzOverflow="overflow" vert="horz" wrap="square" lIns="91440" tIns="45720" rIns="91440" bIns="45720" numCol="1" spcCol="0" rtlCol="0" fromWordArt="0" anchor="ctr" anchorCtr="0" forceAA="0" compatLnSpc="1">
-            <a:prstTxWarp prst="textNoShape">
-              <a:avLst/>
-            </a:prstTxWarp>
-            <a:noAutofit/>
-          </a:bodyPr>
-          <a:lstStyle/>
-          <a:p>
-            <a:pPr algn="ctr"/>
-            <a:endParaRPr lang="en-US"/>
-          </a:p>
-        </p:txBody>
-      </p:sp>
-      <p:sp>
-        <p:nvSpPr>
-          <p:cNvPr id="34" name="Oval 33">
-            <a:extLst>
-              <a:ext uri="{FF2B5EF4-FFF2-40B4-BE49-F238E27FC236}">
-                <a16:creationId xmlns:a16="http://schemas.microsoft.com/office/drawing/2014/main" id="{1CD18BB3-2807-1A40-8F29-9A6CA636A238}"/>
-              </a:ext>
-            </a:extLst>
-          </p:cNvPr>
-          <p:cNvSpPr/>
-          <p:nvPr/>
-        </p:nvSpPr>
-        <p:spPr>
-          <a:xfrm>
-            <a:off x="1028400" y="1556442"/>
-            <a:ext cx="69850" cy="76199"/>
-          </a:xfrm>
-          <a:prstGeom prst="ellipse">
-            <a:avLst/>
-          </a:prstGeom>
-          <a:solidFill>
-            <a:schemeClr val="accent1"/>
-          </a:solidFill>
-          <a:ln>
-            <a:solidFill>
-              <a:schemeClr val="tx1"/>
-            </a:solidFill>
-          </a:ln>
-        </p:spPr>
-        <p:style>
-          <a:lnRef idx="2">
-            <a:schemeClr val="accent1">
-              <a:shade val="50000"/>
-            </a:schemeClr>
-          </a:lnRef>
-          <a:fillRef idx="1">
-            <a:schemeClr val="accent1"/>
-          </a:fillRef>
-          <a:effectRef idx="0">
-            <a:schemeClr val="accent1"/>
-          </a:effectRef>
-          <a:fontRef idx="minor">
-            <a:schemeClr val="lt1"/>
-          </a:fontRef>
-        </p:style>
-        <p:txBody>
-          <a:bodyPr rot="0" spcFirstLastPara="0" vertOverflow="overflow" horzOverflow="overflow" vert="horz" wrap="square" lIns="91440" tIns="45720" rIns="91440" bIns="45720" numCol="1" spcCol="0" rtlCol="0" fromWordArt="0" anchor="ctr" anchorCtr="0" forceAA="0" compatLnSpc="1">
-            <a:prstTxWarp prst="textNoShape">
-              <a:avLst/>
-            </a:prstTxWarp>
-            <a:noAutofit/>
-          </a:bodyPr>
-          <a:lstStyle/>
-          <a:p>
-            <a:pPr algn="ctr"/>
-            <a:endParaRPr lang="en-US"/>
-          </a:p>
-        </p:txBody>
-      </p:sp>
-      <p:sp>
-        <p:nvSpPr>
-          <p:cNvPr id="35" name="Oval 34">
-            <a:extLst>
-              <a:ext uri="{FF2B5EF4-FFF2-40B4-BE49-F238E27FC236}">
-                <a16:creationId xmlns:a16="http://schemas.microsoft.com/office/drawing/2014/main" id="{9C401561-8537-DF4B-A807-0FFE73D3A369}"/>
-              </a:ext>
-            </a:extLst>
-          </p:cNvPr>
-          <p:cNvSpPr/>
-          <p:nvPr/>
-        </p:nvSpPr>
-        <p:spPr>
-          <a:xfrm>
-            <a:off x="1029217" y="1684278"/>
-            <a:ext cx="69850" cy="76199"/>
-          </a:xfrm>
-          <a:prstGeom prst="ellipse">
-            <a:avLst/>
-          </a:prstGeom>
-          <a:solidFill>
-            <a:schemeClr val="accent1"/>
-          </a:solidFill>
-          <a:ln>
-            <a:solidFill>
-              <a:schemeClr val="tx1"/>
-            </a:solidFill>
-          </a:ln>
-        </p:spPr>
-        <p:style>
-          <a:lnRef idx="2">
-            <a:schemeClr val="accent1">
-              <a:shade val="50000"/>
-            </a:schemeClr>
-          </a:lnRef>
-          <a:fillRef idx="1">
-            <a:schemeClr val="accent1"/>
-          </a:fillRef>
-          <a:effectRef idx="0">
-            <a:schemeClr val="accent1"/>
-          </a:effectRef>
-          <a:fontRef idx="minor">
-            <a:schemeClr val="lt1"/>
-          </a:fontRef>
-        </p:style>
-        <p:txBody>
-          <a:bodyPr rot="0" spcFirstLastPara="0" vertOverflow="overflow" horzOverflow="overflow" vert="horz" wrap="square" lIns="91440" tIns="45720" rIns="91440" bIns="45720" numCol="1" spcCol="0" rtlCol="0" fromWordArt="0" anchor="ctr" anchorCtr="0" forceAA="0" compatLnSpc="1">
-            <a:prstTxWarp prst="textNoShape">
-              <a:avLst/>
-            </a:prstTxWarp>
-            <a:noAutofit/>
-          </a:bodyPr>
-          <a:lstStyle/>
-          <a:p>
-            <a:pPr algn="ctr"/>
-            <a:endParaRPr lang="en-US"/>
-          </a:p>
-        </p:txBody>
-      </p:sp>
-      <p:sp>
-        <p:nvSpPr>
-          <p:cNvPr id="36" name="Oval 35">
-            <a:extLst>
-              <a:ext uri="{FF2B5EF4-FFF2-40B4-BE49-F238E27FC236}">
-                <a16:creationId xmlns:a16="http://schemas.microsoft.com/office/drawing/2014/main" id="{115FBDFC-A6C4-C34E-AA41-87B91C50BACE}"/>
-              </a:ext>
-            </a:extLst>
-          </p:cNvPr>
-          <p:cNvSpPr/>
-          <p:nvPr/>
-        </p:nvSpPr>
-        <p:spPr>
-          <a:xfrm>
-            <a:off x="2196499" y="1478658"/>
-            <a:ext cx="69850" cy="76199"/>
-          </a:xfrm>
-          <a:prstGeom prst="ellipse">
-            <a:avLst/>
-          </a:prstGeom>
-          <a:solidFill>
-            <a:schemeClr val="accent1"/>
-          </a:solidFill>
-          <a:ln>
-            <a:solidFill>
-              <a:schemeClr val="tx1"/>
-            </a:solidFill>
-          </a:ln>
-        </p:spPr>
-        <p:style>
-          <a:lnRef idx="2">
-            <a:schemeClr val="accent1">
-              <a:shade val="50000"/>
-            </a:schemeClr>
-          </a:lnRef>
-          <a:fillRef idx="1">
-            <a:schemeClr val="accent1"/>
-          </a:fillRef>
-          <a:effectRef idx="0">
-            <a:schemeClr val="accent1"/>
-          </a:effectRef>
-          <a:fontRef idx="minor">
-            <a:schemeClr val="lt1"/>
-          </a:fontRef>
-        </p:style>
-        <p:txBody>
-          <a:bodyPr rot="0" spcFirstLastPara="0" vertOverflow="overflow" horzOverflow="overflow" vert="horz" wrap="square" lIns="91440" tIns="45720" rIns="91440" bIns="45720" numCol="1" spcCol="0" rtlCol="0" fromWordArt="0" anchor="ctr" anchorCtr="0" forceAA="0" compatLnSpc="1">
-            <a:prstTxWarp prst="textNoShape">
-              <a:avLst/>
-            </a:prstTxWarp>
-            <a:noAutofit/>
-          </a:bodyPr>
-          <a:lstStyle/>
-          <a:p>
-            <a:pPr algn="ctr"/>
-            <a:endParaRPr lang="en-US"/>
-          </a:p>
-        </p:txBody>
-      </p:sp>
-      <p:sp>
-        <p:nvSpPr>
-          <p:cNvPr id="37" name="Oval 36">
-            <a:extLst>
-              <a:ext uri="{FF2B5EF4-FFF2-40B4-BE49-F238E27FC236}">
-                <a16:creationId xmlns:a16="http://schemas.microsoft.com/office/drawing/2014/main" id="{9713E4A0-6BE2-5347-A7AB-2A6F8C467DC8}"/>
-              </a:ext>
-            </a:extLst>
-          </p:cNvPr>
-          <p:cNvSpPr/>
-          <p:nvPr/>
-        </p:nvSpPr>
-        <p:spPr>
-          <a:xfrm>
-            <a:off x="1025742" y="1422505"/>
-            <a:ext cx="69850" cy="76199"/>
-          </a:xfrm>
-          <a:prstGeom prst="ellipse">
-            <a:avLst/>
-          </a:prstGeom>
-          <a:solidFill>
-            <a:schemeClr val="accent1"/>
-          </a:solidFill>
-          <a:ln>
-            <a:solidFill>
-              <a:schemeClr val="tx1"/>
-            </a:solidFill>
-          </a:ln>
-        </p:spPr>
-        <p:style>
-          <a:lnRef idx="2">
-            <a:schemeClr val="accent1">
-              <a:shade val="50000"/>
-            </a:schemeClr>
-          </a:lnRef>
-          <a:fillRef idx="1">
-            <a:schemeClr val="accent1"/>
-          </a:fillRef>
-          <a:effectRef idx="0">
-            <a:schemeClr val="accent1"/>
-          </a:effectRef>
-          <a:fontRef idx="minor">
-            <a:schemeClr val="lt1"/>
-          </a:fontRef>
-        </p:style>
-        <p:txBody>
-          <a:bodyPr rot="0" spcFirstLastPara="0" vertOverflow="overflow" horzOverflow="overflow" vert="horz" wrap="square" lIns="91440" tIns="45720" rIns="91440" bIns="45720" numCol="1" spcCol="0" rtlCol="0" fromWordArt="0" anchor="ctr" anchorCtr="0" forceAA="0" compatLnSpc="1">
-            <a:prstTxWarp prst="textNoShape">
-              <a:avLst/>
-            </a:prstTxWarp>
-            <a:noAutofit/>
-          </a:bodyPr>
-          <a:lstStyle/>
-          <a:p>
-            <a:pPr algn="ctr"/>
-            <a:endParaRPr lang="en-US"/>
-          </a:p>
-        </p:txBody>
-      </p:sp>
-      <p:sp>
-        <p:nvSpPr>
-          <p:cNvPr id="38" name="Oval 37">
-            <a:extLst>
-              <a:ext uri="{FF2B5EF4-FFF2-40B4-BE49-F238E27FC236}">
-                <a16:creationId xmlns:a16="http://schemas.microsoft.com/office/drawing/2014/main" id="{2140E5E6-23BD-B042-A960-12D2F2800EDA}"/>
-              </a:ext>
-            </a:extLst>
-          </p:cNvPr>
-          <p:cNvSpPr/>
-          <p:nvPr/>
-        </p:nvSpPr>
-        <p:spPr>
-          <a:xfrm>
-            <a:off x="3599054" y="1199202"/>
-            <a:ext cx="69850" cy="76199"/>
-          </a:xfrm>
-          <a:prstGeom prst="ellipse">
-            <a:avLst/>
-          </a:prstGeom>
-          <a:solidFill>
-            <a:schemeClr val="accent1"/>
-          </a:solidFill>
-          <a:ln>
-            <a:solidFill>
-              <a:schemeClr val="tx1"/>
-            </a:solidFill>
-          </a:ln>
-        </p:spPr>
-        <p:style>
-          <a:lnRef idx="2">
-            <a:schemeClr val="accent1">
-              <a:shade val="50000"/>
-            </a:schemeClr>
-          </a:lnRef>
-          <a:fillRef idx="1">
-            <a:schemeClr val="accent1"/>
-          </a:fillRef>
-          <a:effectRef idx="0">
-            <a:schemeClr val="accent1"/>
-          </a:effectRef>
-          <a:fontRef idx="minor">
-            <a:schemeClr val="lt1"/>
-          </a:fontRef>
-        </p:style>
-        <p:txBody>
-          <a:bodyPr rot="0" spcFirstLastPara="0" vertOverflow="overflow" horzOverflow="overflow" vert="horz" wrap="square" lIns="91440" tIns="45720" rIns="91440" bIns="45720" numCol="1" spcCol="0" rtlCol="0" fromWordArt="0" anchor="ctr" anchorCtr="0" forceAA="0" compatLnSpc="1">
-            <a:prstTxWarp prst="textNoShape">
-              <a:avLst/>
-            </a:prstTxWarp>
-            <a:noAutofit/>
-          </a:bodyPr>
-          <a:lstStyle/>
-          <a:p>
-            <a:pPr algn="ctr"/>
-            <a:endParaRPr lang="en-US"/>
-          </a:p>
-        </p:txBody>
-      </p:sp>
-      <p:sp>
-        <p:nvSpPr>
-          <p:cNvPr id="39" name="Oval 38">
-            <a:extLst>
-              <a:ext uri="{FF2B5EF4-FFF2-40B4-BE49-F238E27FC236}">
-                <a16:creationId xmlns:a16="http://schemas.microsoft.com/office/drawing/2014/main" id="{6BF01C63-5E90-4841-84A0-DC3B5B229673}"/>
-              </a:ext>
-            </a:extLst>
-          </p:cNvPr>
-          <p:cNvSpPr/>
-          <p:nvPr/>
-        </p:nvSpPr>
-        <p:spPr>
-          <a:xfrm>
-            <a:off x="3564129" y="1263007"/>
-            <a:ext cx="69850" cy="76199"/>
-          </a:xfrm>
-          <a:prstGeom prst="ellipse">
-            <a:avLst/>
-          </a:prstGeom>
-          <a:solidFill>
-            <a:schemeClr val="accent1"/>
-          </a:solidFill>
-          <a:ln>
-            <a:solidFill>
-              <a:schemeClr val="tx1"/>
-            </a:solidFill>
-          </a:ln>
-        </p:spPr>
-        <p:style>
-          <a:lnRef idx="2">
-            <a:schemeClr val="accent1">
-              <a:shade val="50000"/>
-            </a:schemeClr>
-          </a:lnRef>
-          <a:fillRef idx="1">
-            <a:schemeClr val="accent1"/>
-          </a:fillRef>
-          <a:effectRef idx="0">
-            <a:schemeClr val="accent1"/>
-          </a:effectRef>
-          <a:fontRef idx="minor">
-            <a:schemeClr val="lt1"/>
-          </a:fontRef>
-        </p:style>
-        <p:txBody>
-          <a:bodyPr rot="0" spcFirstLastPara="0" vertOverflow="overflow" horzOverflow="overflow" vert="horz" wrap="square" lIns="91440" tIns="45720" rIns="91440" bIns="45720" numCol="1" spcCol="0" rtlCol="0" fromWordArt="0" anchor="ctr" anchorCtr="0" forceAA="0" compatLnSpc="1">
-            <a:prstTxWarp prst="textNoShape">
-              <a:avLst/>
-            </a:prstTxWarp>
-            <a:noAutofit/>
-          </a:bodyPr>
-          <a:lstStyle/>
-          <a:p>
-            <a:pPr algn="ctr"/>
-            <a:endParaRPr lang="en-US"/>
-          </a:p>
-        </p:txBody>
-      </p:sp>
-      <p:sp>
-        <p:nvSpPr>
-          <p:cNvPr id="40" name="Oval 39">
-            <a:extLst>
-              <a:ext uri="{FF2B5EF4-FFF2-40B4-BE49-F238E27FC236}">
-                <a16:creationId xmlns:a16="http://schemas.microsoft.com/office/drawing/2014/main" id="{AE5F4321-71D3-474E-8003-915074DDCE8E}"/>
-              </a:ext>
-            </a:extLst>
-          </p:cNvPr>
-          <p:cNvSpPr/>
-          <p:nvPr/>
-        </p:nvSpPr>
-        <p:spPr>
-          <a:xfrm>
-            <a:off x="3281736" y="1445896"/>
-            <a:ext cx="69850" cy="76199"/>
-          </a:xfrm>
-          <a:prstGeom prst="ellipse">
-            <a:avLst/>
-          </a:prstGeom>
-          <a:solidFill>
-            <a:schemeClr val="accent1"/>
-          </a:solidFill>
-          <a:ln>
-            <a:solidFill>
-              <a:schemeClr val="tx1"/>
-            </a:solidFill>
-          </a:ln>
-        </p:spPr>
-        <p:style>
-          <a:lnRef idx="2">
-            <a:schemeClr val="accent1">
-              <a:shade val="50000"/>
-            </a:schemeClr>
-          </a:lnRef>
-          <a:fillRef idx="1">
-            <a:schemeClr val="accent1"/>
-          </a:fillRef>
-          <a:effectRef idx="0">
-            <a:schemeClr val="accent1"/>
-          </a:effectRef>
-          <a:fontRef idx="minor">
-            <a:schemeClr val="lt1"/>
-          </a:fontRef>
-        </p:style>
-        <p:txBody>
-          <a:bodyPr rot="0" spcFirstLastPara="0" vertOverflow="overflow" horzOverflow="overflow" vert="horz" wrap="square" lIns="91440" tIns="45720" rIns="91440" bIns="45720" numCol="1" spcCol="0" rtlCol="0" fromWordArt="0" anchor="ctr" anchorCtr="0" forceAA="0" compatLnSpc="1">
-            <a:prstTxWarp prst="textNoShape">
-              <a:avLst/>
-            </a:prstTxWarp>
-            <a:noAutofit/>
-          </a:bodyPr>
-          <a:lstStyle/>
-          <a:p>
-            <a:pPr algn="ctr"/>
-            <a:endParaRPr lang="en-US"/>
-          </a:p>
-        </p:txBody>
-      </p:sp>
-      <p:sp>
-        <p:nvSpPr>
-          <p:cNvPr id="41" name="Oval 40">
-            <a:extLst>
-              <a:ext uri="{FF2B5EF4-FFF2-40B4-BE49-F238E27FC236}">
-                <a16:creationId xmlns:a16="http://schemas.microsoft.com/office/drawing/2014/main" id="{215CB7C1-B293-7E41-BFBB-4167449BC67C}"/>
-              </a:ext>
-            </a:extLst>
-          </p:cNvPr>
-          <p:cNvSpPr/>
-          <p:nvPr/>
-        </p:nvSpPr>
-        <p:spPr>
-          <a:xfrm>
-            <a:off x="3365440" y="1473097"/>
-            <a:ext cx="69850" cy="76199"/>
-          </a:xfrm>
-          <a:prstGeom prst="ellipse">
-            <a:avLst/>
-          </a:prstGeom>
-          <a:solidFill>
-            <a:schemeClr val="accent1"/>
-          </a:solidFill>
-          <a:ln>
-            <a:solidFill>
-              <a:schemeClr val="tx1"/>
-            </a:solidFill>
-          </a:ln>
-        </p:spPr>
-        <p:style>
-          <a:lnRef idx="2">
-            <a:schemeClr val="accent1">
-              <a:shade val="50000"/>
-            </a:schemeClr>
-          </a:lnRef>
-          <a:fillRef idx="1">
-            <a:schemeClr val="accent1"/>
-          </a:fillRef>
-          <a:effectRef idx="0">
-            <a:schemeClr val="accent1"/>
-          </a:effectRef>
-          <a:fontRef idx="minor">
-            <a:schemeClr val="lt1"/>
-          </a:fontRef>
-        </p:style>
-        <p:txBody>
-          <a:bodyPr rot="0" spcFirstLastPara="0" vertOverflow="overflow" horzOverflow="overflow" vert="horz" wrap="square" lIns="91440" tIns="45720" rIns="91440" bIns="45720" numCol="1" spcCol="0" rtlCol="0" fromWordArt="0" anchor="ctr" anchorCtr="0" forceAA="0" compatLnSpc="1">
-            <a:prstTxWarp prst="textNoShape">
-              <a:avLst/>
-            </a:prstTxWarp>
-            <a:noAutofit/>
-          </a:bodyPr>
-          <a:lstStyle/>
-          <a:p>
-            <a:pPr algn="ctr"/>
-            <a:endParaRPr lang="en-US"/>
-          </a:p>
-        </p:txBody>
-      </p:sp>
-      <p:sp>
-        <p:nvSpPr>
-          <p:cNvPr id="42" name="Oval 41">
-            <a:extLst>
-              <a:ext uri="{FF2B5EF4-FFF2-40B4-BE49-F238E27FC236}">
-                <a16:creationId xmlns:a16="http://schemas.microsoft.com/office/drawing/2014/main" id="{EE916DAD-0B82-F947-8E4B-90557900E9AF}"/>
-              </a:ext>
-            </a:extLst>
-          </p:cNvPr>
-          <p:cNvSpPr/>
-          <p:nvPr/>
-        </p:nvSpPr>
-        <p:spPr>
-          <a:xfrm>
-            <a:off x="3481507" y="1467181"/>
-            <a:ext cx="69850" cy="76199"/>
-          </a:xfrm>
-          <a:prstGeom prst="ellipse">
-            <a:avLst/>
-          </a:prstGeom>
-          <a:solidFill>
-            <a:schemeClr val="accent1"/>
-          </a:solidFill>
-          <a:ln>
-            <a:solidFill>
-              <a:schemeClr val="tx1"/>
-            </a:solidFill>
-          </a:ln>
-        </p:spPr>
-        <p:style>
-          <a:lnRef idx="2">
-            <a:schemeClr val="accent1">
-              <a:shade val="50000"/>
-            </a:schemeClr>
-          </a:lnRef>
-          <a:fillRef idx="1">
-            <a:schemeClr val="accent1"/>
-          </a:fillRef>
-          <a:effectRef idx="0">
-            <a:schemeClr val="accent1"/>
-          </a:effectRef>
-          <a:fontRef idx="minor">
-            <a:schemeClr val="lt1"/>
-          </a:fontRef>
-        </p:style>
-        <p:txBody>
-          <a:bodyPr rot="0" spcFirstLastPara="0" vertOverflow="overflow" horzOverflow="overflow" vert="horz" wrap="square" lIns="91440" tIns="45720" rIns="91440" bIns="45720" numCol="1" spcCol="0" rtlCol="0" fromWordArt="0" anchor="ctr" anchorCtr="0" forceAA="0" compatLnSpc="1">
-            <a:prstTxWarp prst="textNoShape">
-              <a:avLst/>
-            </a:prstTxWarp>
-            <a:noAutofit/>
-          </a:bodyPr>
-          <a:lstStyle/>
-          <a:p>
-            <a:pPr algn="ctr"/>
-            <a:endParaRPr lang="en-US"/>
-          </a:p>
-        </p:txBody>
-      </p:sp>
-      <p:sp>
-        <p:nvSpPr>
-          <p:cNvPr id="43" name="Oval 42">
-            <a:extLst>
-              <a:ext uri="{FF2B5EF4-FFF2-40B4-BE49-F238E27FC236}">
-                <a16:creationId xmlns:a16="http://schemas.microsoft.com/office/drawing/2014/main" id="{1EC4C1AB-77CF-6D4C-B377-015D3077CCED}"/>
-              </a:ext>
-            </a:extLst>
-          </p:cNvPr>
-          <p:cNvSpPr/>
-          <p:nvPr/>
-        </p:nvSpPr>
-        <p:spPr>
-          <a:xfrm>
-            <a:off x="1796537" y="330765"/>
-            <a:ext cx="69850" cy="76199"/>
-          </a:xfrm>
-          <a:prstGeom prst="ellipse">
-            <a:avLst/>
-          </a:prstGeom>
-          <a:solidFill>
-            <a:srgbClr val="7030A0"/>
-          </a:solidFill>
-          <a:ln>
-            <a:solidFill>
-              <a:schemeClr val="tx1"/>
-            </a:solidFill>
-          </a:ln>
-        </p:spPr>
-        <p:style>
-          <a:lnRef idx="2">
-            <a:schemeClr val="accent1">
-              <a:shade val="50000"/>
-            </a:schemeClr>
-          </a:lnRef>
-          <a:fillRef idx="1">
-            <a:schemeClr val="accent1"/>
-          </a:fillRef>
-          <a:effectRef idx="0">
-            <a:schemeClr val="accent1"/>
-          </a:effectRef>
-          <a:fontRef idx="minor">
-            <a:schemeClr val="lt1"/>
-          </a:fontRef>
-        </p:style>
-        <p:txBody>
-          <a:bodyPr rot="0" spcFirstLastPara="0" vertOverflow="overflow" horzOverflow="overflow" vert="horz" wrap="square" lIns="91440" tIns="45720" rIns="91440" bIns="45720" numCol="1" spcCol="0" rtlCol="0" fromWordArt="0" anchor="ctr" anchorCtr="0" forceAA="0" compatLnSpc="1">
-            <a:prstTxWarp prst="textNoShape">
-              <a:avLst/>
-            </a:prstTxWarp>
-            <a:noAutofit/>
-          </a:bodyPr>
-          <a:lstStyle/>
-          <a:p>
-            <a:pPr algn="ctr"/>
-            <a:endParaRPr lang="en-US"/>
-          </a:p>
-        </p:txBody>
-      </p:sp>
-      <p:sp>
-        <p:nvSpPr>
-          <p:cNvPr id="44" name="TextBox 43">
-            <a:extLst>
-              <a:ext uri="{FF2B5EF4-FFF2-40B4-BE49-F238E27FC236}">
-                <a16:creationId xmlns:a16="http://schemas.microsoft.com/office/drawing/2014/main" id="{83ABEE19-82BB-9146-AD09-A011A13B50D9}"/>
+                <a16:creationId xmlns:a16="http://schemas.microsoft.com/office/drawing/2014/main" id="{D25117AD-466F-444B-A752-5E9FA80F0392}"/>
               </a:ext>
             </a:extLst>
           </p:cNvPr>
@@ -4750,7 +3045,7 @@
         </p:nvSpPr>
         <p:spPr>
           <a:xfrm>
-            <a:off x="25739" y="37630"/>
+            <a:off x="5940789" y="-11057"/>
             <a:ext cx="421910" cy="584775"/>
           </a:xfrm>
           <a:prstGeom prst="rect">
@@ -4773,10 +3068,10 @@
       </p:sp>
       <p:sp>
         <p:nvSpPr>
-          <p:cNvPr id="45" name="TextBox 44">
+          <p:cNvPr id="16" name="TextBox 15">
             <a:extLst>
               <a:ext uri="{FF2B5EF4-FFF2-40B4-BE49-F238E27FC236}">
-                <a16:creationId xmlns:a16="http://schemas.microsoft.com/office/drawing/2014/main" id="{7B194326-93AF-534D-9DA0-3D3FA6A522DD}"/>
+                <a16:creationId xmlns:a16="http://schemas.microsoft.com/office/drawing/2014/main" id="{7BD54EA7-2025-C643-8B2A-CB811897852F}"/>
               </a:ext>
             </a:extLst>
           </p:cNvPr>
@@ -4785,7 +3080,7 @@
         </p:nvSpPr>
         <p:spPr>
           <a:xfrm>
-            <a:off x="31062" y="3962067"/>
+            <a:off x="5955215" y="2641426"/>
             <a:ext cx="407484" cy="584775"/>
           </a:xfrm>
           <a:prstGeom prst="rect">
@@ -4809,7 +3104,7 @@
     </p:spTree>
     <p:extLst>
       <p:ext uri="{BB962C8B-B14F-4D97-AF65-F5344CB8AC3E}">
-        <p14:creationId xmlns:p14="http://schemas.microsoft.com/office/powerpoint/2010/main" val="2409556956"/>
+        <p14:creationId xmlns:p14="http://schemas.microsoft.com/office/powerpoint/2010/main" val="563687868"/>
       </p:ext>
     </p:extLst>
   </p:cSld>

</xml_diff>

<commit_message>
last fig2 for now
</commit_message>
<xml_diff>
--- a/Output/Pub_figs/FIg2.pptx
+++ b/Output/Pub_figs/FIg2.pptx
@@ -2973,10 +2973,10 @@
       </p:grpSpPr>
       <p:pic>
         <p:nvPicPr>
-          <p:cNvPr id="7" name="Picture 6">
+          <p:cNvPr id="8" name="Picture 7">
             <a:extLst>
               <a:ext uri="{FF2B5EF4-FFF2-40B4-BE49-F238E27FC236}">
-                <a16:creationId xmlns:a16="http://schemas.microsoft.com/office/drawing/2014/main" id="{B235B9D6-4844-8E4B-A077-E75CD5AA0C34}"/>
+                <a16:creationId xmlns:a16="http://schemas.microsoft.com/office/drawing/2014/main" id="{5F9137E3-9FDC-A142-8249-3A62A8A9F40A}"/>
               </a:ext>
             </a:extLst>
           </p:cNvPr>
@@ -2993,7 +2993,7 @@
         </p:blipFill>
         <p:spPr>
           <a:xfrm>
-            <a:off x="0" y="0"/>
+            <a:off x="3175" y="0"/>
             <a:ext cx="6477000" cy="2743200"/>
           </a:xfrm>
           <a:prstGeom prst="rect">
@@ -3003,10 +3003,10 @@
       </p:pic>
       <p:pic>
         <p:nvPicPr>
-          <p:cNvPr id="11" name="Picture 10">
+          <p:cNvPr id="10" name="Picture 9">
             <a:extLst>
               <a:ext uri="{FF2B5EF4-FFF2-40B4-BE49-F238E27FC236}">
-                <a16:creationId xmlns:a16="http://schemas.microsoft.com/office/drawing/2014/main" id="{934A2634-4E01-9146-97BE-6321FFAF08EB}"/>
+                <a16:creationId xmlns:a16="http://schemas.microsoft.com/office/drawing/2014/main" id="{5830381E-F7FA-4847-BD84-2416486CF03E}"/>
               </a:ext>
             </a:extLst>
           </p:cNvPr>
@@ -3023,7 +3023,7 @@
         </p:blipFill>
         <p:spPr>
           <a:xfrm>
-            <a:off x="0" y="2695344"/>
+            <a:off x="3175" y="2743200"/>
             <a:ext cx="6477000" cy="3657600"/>
           </a:xfrm>
           <a:prstGeom prst="rect">

</xml_diff>